<commit_message>
chore: Addition info added
</commit_message>
<xml_diff>
--- a/Home_done_works/Documents/pptformats/LearningOfGit.pptx
+++ b/Home_done_works/Documents/pptformats/LearningOfGit.pptx
@@ -4,6 +4,9 @@
   <p:sldMasterIdLst>
     <p:sldMasterId id="2147483648" r:id="rId1"/>
   </p:sldMasterIdLst>
+  <p:notesMasterIdLst>
+    <p:notesMasterId r:id="rId11"/>
+  </p:notesMasterIdLst>
   <p:sldIdLst>
     <p:sldId id="256" r:id="rId2"/>
     <p:sldId id="257" r:id="rId3"/>
@@ -11,8 +14,9 @@
     <p:sldId id="259" r:id="rId5"/>
     <p:sldId id="263" r:id="rId6"/>
     <p:sldId id="260" r:id="rId7"/>
-    <p:sldId id="261" r:id="rId8"/>
-    <p:sldId id="262" r:id="rId9"/>
+    <p:sldId id="264" r:id="rId8"/>
+    <p:sldId id="261" r:id="rId9"/>
+    <p:sldId id="262" r:id="rId10"/>
   </p:sldIdLst>
   <p:sldSz cx="12192000" cy="6858000"/>
   <p:notesSz cx="6858000" cy="9144000"/>
@@ -111,7 +115,362 @@
       </a:defRPr>
     </a:lvl9pPr>
   </p:defaultTextStyle>
+  <p:extLst>
+    <p:ext uri="{EFAFB233-063F-42B5-8137-9DF3F51BA10A}">
+      <p15:sldGuideLst xmlns:p15="http://schemas.microsoft.com/office/powerpoint/2012/main"/>
+    </p:ext>
+  </p:extLst>
 </p:presentation>
+</file>
+
+<file path=ppt/notesMasters/notesMaster1.xml><?xml version="1.0" encoding="utf-8"?>
+<p:notesMaster xmlns:a="http://schemas.openxmlformats.org/drawingml/2006/main" xmlns:r="http://schemas.openxmlformats.org/officeDocument/2006/relationships" xmlns:p="http://schemas.openxmlformats.org/presentationml/2006/main">
+  <p:cSld>
+    <p:bg>
+      <p:bgRef idx="1001">
+        <a:schemeClr val="bg1"/>
+      </p:bgRef>
+    </p:bg>
+    <p:spTree>
+      <p:nvGrpSpPr>
+        <p:cNvPr id="1" name=""/>
+        <p:cNvGrpSpPr/>
+        <p:nvPr/>
+      </p:nvGrpSpPr>
+      <p:grpSpPr>
+        <a:xfrm>
+          <a:off x="0" y="0"/>
+          <a:ext cx="0" cy="0"/>
+          <a:chOff x="0" y="0"/>
+          <a:chExt cx="0" cy="0"/>
+        </a:xfrm>
+      </p:grpSpPr>
+      <p:sp>
+        <p:nvSpPr>
+          <p:cNvPr id="2" name="Header Placeholder 1"/>
+          <p:cNvSpPr>
+            <a:spLocks noGrp="1"/>
+          </p:cNvSpPr>
+          <p:nvPr>
+            <p:ph type="hdr" sz="quarter"/>
+          </p:nvPr>
+        </p:nvSpPr>
+        <p:spPr>
+          <a:xfrm>
+            <a:off x="0" y="0"/>
+            <a:ext cx="2971800" cy="458788"/>
+          </a:xfrm>
+          <a:prstGeom prst="rect">
+            <a:avLst/>
+          </a:prstGeom>
+        </p:spPr>
+        <p:txBody>
+          <a:bodyPr vert="horz" lIns="91440" tIns="45720" rIns="91440" bIns="45720" rtlCol="0"/>
+          <a:lstStyle>
+            <a:lvl1pPr algn="l">
+              <a:defRPr sz="1200"/>
+            </a:lvl1pPr>
+          </a:lstStyle>
+          <a:p>
+            <a:endParaRPr lang="en-IN"/>
+          </a:p>
+        </p:txBody>
+      </p:sp>
+      <p:sp>
+        <p:nvSpPr>
+          <p:cNvPr id="3" name="Date Placeholder 2"/>
+          <p:cNvSpPr>
+            <a:spLocks noGrp="1"/>
+          </p:cNvSpPr>
+          <p:nvPr>
+            <p:ph type="dt" idx="1"/>
+          </p:nvPr>
+        </p:nvSpPr>
+        <p:spPr>
+          <a:xfrm>
+            <a:off x="3884613" y="0"/>
+            <a:ext cx="2971800" cy="458788"/>
+          </a:xfrm>
+          <a:prstGeom prst="rect">
+            <a:avLst/>
+          </a:prstGeom>
+        </p:spPr>
+        <p:txBody>
+          <a:bodyPr vert="horz" lIns="91440" tIns="45720" rIns="91440" bIns="45720" rtlCol="0"/>
+          <a:lstStyle>
+            <a:lvl1pPr algn="r">
+              <a:defRPr sz="1200"/>
+            </a:lvl1pPr>
+          </a:lstStyle>
+          <a:p>
+            <a:fld id="{9163DBCC-5E4F-4FD2-980C-39FABB77CABB}" type="datetimeFigureOut">
+              <a:rPr lang="en-IN" smtClean="0"/>
+              <a:t>26-01-2025</a:t>
+            </a:fld>
+            <a:endParaRPr lang="en-IN"/>
+          </a:p>
+        </p:txBody>
+      </p:sp>
+      <p:sp>
+        <p:nvSpPr>
+          <p:cNvPr id="4" name="Slide Image Placeholder 3"/>
+          <p:cNvSpPr>
+            <a:spLocks noGrp="1" noRot="1" noChangeAspect="1"/>
+          </p:cNvSpPr>
+          <p:nvPr>
+            <p:ph type="sldImg" idx="2"/>
+          </p:nvPr>
+        </p:nvSpPr>
+        <p:spPr>
+          <a:xfrm>
+            <a:off x="685800" y="1143000"/>
+            <a:ext cx="5486400" cy="3086100"/>
+          </a:xfrm>
+          <a:prstGeom prst="rect">
+            <a:avLst/>
+          </a:prstGeom>
+          <a:noFill/>
+          <a:ln w="12700">
+            <a:solidFill>
+              <a:prstClr val="black"/>
+            </a:solidFill>
+          </a:ln>
+        </p:spPr>
+        <p:txBody>
+          <a:bodyPr vert="horz" lIns="91440" tIns="45720" rIns="91440" bIns="45720" rtlCol="0" anchor="ctr"/>
+          <a:lstStyle/>
+          <a:p>
+            <a:endParaRPr lang="en-IN"/>
+          </a:p>
+        </p:txBody>
+      </p:sp>
+      <p:sp>
+        <p:nvSpPr>
+          <p:cNvPr id="5" name="Notes Placeholder 4"/>
+          <p:cNvSpPr>
+            <a:spLocks noGrp="1"/>
+          </p:cNvSpPr>
+          <p:nvPr>
+            <p:ph type="body" sz="quarter" idx="3"/>
+          </p:nvPr>
+        </p:nvSpPr>
+        <p:spPr>
+          <a:xfrm>
+            <a:off x="685800" y="4400550"/>
+            <a:ext cx="5486400" cy="3600450"/>
+          </a:xfrm>
+          <a:prstGeom prst="rect">
+            <a:avLst/>
+          </a:prstGeom>
+        </p:spPr>
+        <p:txBody>
+          <a:bodyPr vert="horz" lIns="91440" tIns="45720" rIns="91440" bIns="45720" rtlCol="0"/>
+          <a:lstStyle/>
+          <a:p>
+            <a:pPr lvl="0"/>
+            <a:r>
+              <a:rPr lang="en-US"/>
+              <a:t>Click to edit Master text styles</a:t>
+            </a:r>
+          </a:p>
+          <a:p>
+            <a:pPr lvl="1"/>
+            <a:r>
+              <a:rPr lang="en-US"/>
+              <a:t>Second level</a:t>
+            </a:r>
+          </a:p>
+          <a:p>
+            <a:pPr lvl="2"/>
+            <a:r>
+              <a:rPr lang="en-US"/>
+              <a:t>Third level</a:t>
+            </a:r>
+          </a:p>
+          <a:p>
+            <a:pPr lvl="3"/>
+            <a:r>
+              <a:rPr lang="en-US"/>
+              <a:t>Fourth level</a:t>
+            </a:r>
+          </a:p>
+          <a:p>
+            <a:pPr lvl="4"/>
+            <a:r>
+              <a:rPr lang="en-US"/>
+              <a:t>Fifth level</a:t>
+            </a:r>
+            <a:endParaRPr lang="en-IN"/>
+          </a:p>
+        </p:txBody>
+      </p:sp>
+      <p:sp>
+        <p:nvSpPr>
+          <p:cNvPr id="6" name="Footer Placeholder 5"/>
+          <p:cNvSpPr>
+            <a:spLocks noGrp="1"/>
+          </p:cNvSpPr>
+          <p:nvPr>
+            <p:ph type="ftr" sz="quarter" idx="4"/>
+          </p:nvPr>
+        </p:nvSpPr>
+        <p:spPr>
+          <a:xfrm>
+            <a:off x="0" y="8685213"/>
+            <a:ext cx="2971800" cy="458787"/>
+          </a:xfrm>
+          <a:prstGeom prst="rect">
+            <a:avLst/>
+          </a:prstGeom>
+        </p:spPr>
+        <p:txBody>
+          <a:bodyPr vert="horz" lIns="91440" tIns="45720" rIns="91440" bIns="45720" rtlCol="0" anchor="b"/>
+          <a:lstStyle>
+            <a:lvl1pPr algn="l">
+              <a:defRPr sz="1200"/>
+            </a:lvl1pPr>
+          </a:lstStyle>
+          <a:p>
+            <a:endParaRPr lang="en-IN"/>
+          </a:p>
+        </p:txBody>
+      </p:sp>
+      <p:sp>
+        <p:nvSpPr>
+          <p:cNvPr id="7" name="Slide Number Placeholder 6"/>
+          <p:cNvSpPr>
+            <a:spLocks noGrp="1"/>
+          </p:cNvSpPr>
+          <p:nvPr>
+            <p:ph type="sldNum" sz="quarter" idx="5"/>
+          </p:nvPr>
+        </p:nvSpPr>
+        <p:spPr>
+          <a:xfrm>
+            <a:off x="3884613" y="8685213"/>
+            <a:ext cx="2971800" cy="458787"/>
+          </a:xfrm>
+          <a:prstGeom prst="rect">
+            <a:avLst/>
+          </a:prstGeom>
+        </p:spPr>
+        <p:txBody>
+          <a:bodyPr vert="horz" lIns="91440" tIns="45720" rIns="91440" bIns="45720" rtlCol="0" anchor="b"/>
+          <a:lstStyle>
+            <a:lvl1pPr algn="r">
+              <a:defRPr sz="1200"/>
+            </a:lvl1pPr>
+          </a:lstStyle>
+          <a:p>
+            <a:fld id="{87A80356-7E11-442B-A266-E3D572B13FC5}" type="slidenum">
+              <a:rPr lang="en-IN" smtClean="0"/>
+              <a:t>‹#›</a:t>
+            </a:fld>
+            <a:endParaRPr lang="en-IN"/>
+          </a:p>
+        </p:txBody>
+      </p:sp>
+    </p:spTree>
+    <p:extLst>
+      <p:ext uri="{BB962C8B-B14F-4D97-AF65-F5344CB8AC3E}">
+        <p14:creationId xmlns:p14="http://schemas.microsoft.com/office/powerpoint/2010/main" val="3701140778"/>
+      </p:ext>
+    </p:extLst>
+  </p:cSld>
+  <p:clrMap bg1="lt1" tx1="dk1" bg2="lt2" tx2="dk2" accent1="accent1" accent2="accent2" accent3="accent3" accent4="accent4" accent5="accent5" accent6="accent6" hlink="hlink" folHlink="folHlink"/>
+  <p:notesStyle>
+    <a:lvl1pPr marL="0" algn="l" defTabSz="914400" rtl="0" eaLnBrk="1" latinLnBrk="0" hangingPunct="1">
+      <a:defRPr sz="1200" kern="1200">
+        <a:solidFill>
+          <a:schemeClr val="tx1"/>
+        </a:solidFill>
+        <a:latin typeface="+mn-lt"/>
+        <a:ea typeface="+mn-ea"/>
+        <a:cs typeface="+mn-cs"/>
+      </a:defRPr>
+    </a:lvl1pPr>
+    <a:lvl2pPr marL="457200" algn="l" defTabSz="914400" rtl="0" eaLnBrk="1" latinLnBrk="0" hangingPunct="1">
+      <a:defRPr sz="1200" kern="1200">
+        <a:solidFill>
+          <a:schemeClr val="tx1"/>
+        </a:solidFill>
+        <a:latin typeface="+mn-lt"/>
+        <a:ea typeface="+mn-ea"/>
+        <a:cs typeface="+mn-cs"/>
+      </a:defRPr>
+    </a:lvl2pPr>
+    <a:lvl3pPr marL="914400" algn="l" defTabSz="914400" rtl="0" eaLnBrk="1" latinLnBrk="0" hangingPunct="1">
+      <a:defRPr sz="1200" kern="1200">
+        <a:solidFill>
+          <a:schemeClr val="tx1"/>
+        </a:solidFill>
+        <a:latin typeface="+mn-lt"/>
+        <a:ea typeface="+mn-ea"/>
+        <a:cs typeface="+mn-cs"/>
+      </a:defRPr>
+    </a:lvl3pPr>
+    <a:lvl4pPr marL="1371600" algn="l" defTabSz="914400" rtl="0" eaLnBrk="1" latinLnBrk="0" hangingPunct="1">
+      <a:defRPr sz="1200" kern="1200">
+        <a:solidFill>
+          <a:schemeClr val="tx1"/>
+        </a:solidFill>
+        <a:latin typeface="+mn-lt"/>
+        <a:ea typeface="+mn-ea"/>
+        <a:cs typeface="+mn-cs"/>
+      </a:defRPr>
+    </a:lvl4pPr>
+    <a:lvl5pPr marL="1828800" algn="l" defTabSz="914400" rtl="0" eaLnBrk="1" latinLnBrk="0" hangingPunct="1">
+      <a:defRPr sz="1200" kern="1200">
+        <a:solidFill>
+          <a:schemeClr val="tx1"/>
+        </a:solidFill>
+        <a:latin typeface="+mn-lt"/>
+        <a:ea typeface="+mn-ea"/>
+        <a:cs typeface="+mn-cs"/>
+      </a:defRPr>
+    </a:lvl5pPr>
+    <a:lvl6pPr marL="2286000" algn="l" defTabSz="914400" rtl="0" eaLnBrk="1" latinLnBrk="0" hangingPunct="1">
+      <a:defRPr sz="1200" kern="1200">
+        <a:solidFill>
+          <a:schemeClr val="tx1"/>
+        </a:solidFill>
+        <a:latin typeface="+mn-lt"/>
+        <a:ea typeface="+mn-ea"/>
+        <a:cs typeface="+mn-cs"/>
+      </a:defRPr>
+    </a:lvl6pPr>
+    <a:lvl7pPr marL="2743200" algn="l" defTabSz="914400" rtl="0" eaLnBrk="1" latinLnBrk="0" hangingPunct="1">
+      <a:defRPr sz="1200" kern="1200">
+        <a:solidFill>
+          <a:schemeClr val="tx1"/>
+        </a:solidFill>
+        <a:latin typeface="+mn-lt"/>
+        <a:ea typeface="+mn-ea"/>
+        <a:cs typeface="+mn-cs"/>
+      </a:defRPr>
+    </a:lvl7pPr>
+    <a:lvl8pPr marL="3200400" algn="l" defTabSz="914400" rtl="0" eaLnBrk="1" latinLnBrk="0" hangingPunct="1">
+      <a:defRPr sz="1200" kern="1200">
+        <a:solidFill>
+          <a:schemeClr val="tx1"/>
+        </a:solidFill>
+        <a:latin typeface="+mn-lt"/>
+        <a:ea typeface="+mn-ea"/>
+        <a:cs typeface="+mn-cs"/>
+      </a:defRPr>
+    </a:lvl8pPr>
+    <a:lvl9pPr marL="3657600" algn="l" defTabSz="914400" rtl="0" eaLnBrk="1" latinLnBrk="0" hangingPunct="1">
+      <a:defRPr sz="1200" kern="1200">
+        <a:solidFill>
+          <a:schemeClr val="tx1"/>
+        </a:solidFill>
+        <a:latin typeface="+mn-lt"/>
+        <a:ea typeface="+mn-ea"/>
+        <a:cs typeface="+mn-cs"/>
+      </a:defRPr>
+    </a:lvl9pPr>
+  </p:notesStyle>
+</p:notesMaster>
 </file>
 
 <file path=ppt/slideLayouts/slideLayout1.xml><?xml version="1.0" encoding="utf-8"?>
@@ -3510,7 +3869,7 @@
             </a:pPr>
             <a:r>
               <a:rPr lang="en-IN" dirty="0"/>
-              <a:t>In local I have work folder to monitor the daily status of work</a:t>
+              <a:t>In local I have task folder to monitor the daily status of task</a:t>
             </a:r>
           </a:p>
           <a:p>
@@ -3519,7 +3878,7 @@
             </a:pPr>
             <a:r>
               <a:rPr lang="en-IN" dirty="0"/>
-              <a:t>In that I have day1 folder to show, what work done to my Trainer</a:t>
+              <a:t>In that I have day1 folder to show, what task done to my Trainer</a:t>
             </a:r>
           </a:p>
           <a:p>
@@ -3528,7 +3887,19 @@
             </a:pPr>
             <a:r>
               <a:rPr lang="en-IN" dirty="0"/>
-              <a:t>in day1 folder I have text file </a:t>
+              <a:t>in </a:t>
+            </a:r>
+            <a:r>
+              <a:rPr lang="en-IN" dirty="0">
+                <a:solidFill>
+                  <a:srgbClr val="FF0000"/>
+                </a:solidFill>
+              </a:rPr>
+              <a:t>task1</a:t>
+            </a:r>
+            <a:r>
+              <a:rPr lang="en-IN" dirty="0"/>
+              <a:t> folder I have text file </a:t>
             </a:r>
             <a:r>
               <a:rPr lang="en-IN" dirty="0" err="1"/>
@@ -3536,7 +3907,7 @@
             </a:r>
             <a:r>
               <a:rPr lang="en-IN" dirty="0"/>
-              <a:t>: in that I have written the</a:t>
+              <a:t>: in that I have written the </a:t>
             </a:r>
           </a:p>
           <a:p>
@@ -3558,7 +3929,15 @@
             </a:pPr>
             <a:r>
               <a:rPr lang="en-IN" dirty="0"/>
-              <a:t>And next day I created another folder with the filename day2 </a:t>
+              <a:t>And next day I created another folder with the filename </a:t>
+            </a:r>
+            <a:r>
+              <a:rPr lang="en-IN" dirty="0">
+                <a:solidFill>
+                  <a:srgbClr val="FF0000"/>
+                </a:solidFill>
+              </a:rPr>
+              <a:t>task2</a:t>
             </a:r>
           </a:p>
           <a:p>
@@ -3580,7 +3959,15 @@
             </a:pPr>
             <a:r>
               <a:rPr lang="en-US" dirty="0"/>
-              <a:t>Same like that day 3</a:t>
+              <a:t>Same like that </a:t>
+            </a:r>
+            <a:r>
+              <a:rPr lang="en-US" dirty="0">
+                <a:solidFill>
+                  <a:srgbClr val="FF0000"/>
+                </a:solidFill>
+              </a:rPr>
+              <a:t>task3</a:t>
             </a:r>
           </a:p>
           <a:p>
@@ -3610,7 +3997,7 @@
             </a:r>
             <a:r>
               <a:rPr lang="en-US" dirty="0"/>
-              <a:t> day what I have done is taken a leave so need document that</a:t>
+              <a:t> day what I have done is taken a leave so need to document that</a:t>
             </a:r>
           </a:p>
           <a:p>
@@ -3738,7 +4125,7 @@
             </a:r>
             <a:r>
               <a:rPr lang="en-US" dirty="0"/>
-              <a:t> day and show the progress of my work in the fine day I notice that  I didn’t do anything so it is empty </a:t>
+              <a:t> day and show the progress of my work.  I noticed that  I didn’t do anything so it is empty.</a:t>
             </a:r>
           </a:p>
           <a:p>
@@ -3747,7 +4134,7 @@
             </a:pPr>
             <a:r>
               <a:rPr lang="en-US" dirty="0"/>
-              <a:t>Trainer ask you don’t do that workout.</a:t>
+              <a:t>Trainer ask you have not  that workout.</a:t>
             </a:r>
           </a:p>
           <a:p>
@@ -3756,7 +4143,16 @@
             </a:pPr>
             <a:r>
               <a:rPr lang="en-US" dirty="0"/>
-              <a:t>So trainer think you have not done anything for the four days at that the time I will show the 1</a:t>
+              <a:t>So trainer think you have not done anything for the four days at that the time</a:t>
+            </a:r>
+          </a:p>
+          <a:p>
+            <a:pPr marL="0" indent="0">
+              <a:buNone/>
+            </a:pPr>
+            <a:r>
+              <a:rPr lang="en-US" dirty="0"/>
+              <a:t> I will show the 1</a:t>
             </a:r>
             <a:r>
               <a:rPr lang="en-US" baseline="30000" dirty="0"/>
@@ -3772,7 +4168,15 @@
             </a:r>
             <a:r>
               <a:rPr lang="en-US" dirty="0"/>
-              <a:t> day work because I keep the copy of that to display </a:t>
+              <a:t> day work because I keep the copy of </a:t>
+            </a:r>
+            <a:r>
+              <a:rPr lang="en-US" dirty="0" err="1"/>
+              <a:t>thatin</a:t>
+            </a:r>
+            <a:r>
+              <a:rPr lang="en-US" dirty="0"/>
+              <a:t> file to display </a:t>
             </a:r>
             <a:br>
               <a:rPr lang="en-US" dirty="0"/>
@@ -3796,7 +4200,15 @@
             </a:r>
             <a:r>
               <a:rPr lang="en-US" dirty="0"/>
-              <a:t> we need each copy of that  to monitor the day one works and day2 works.to keep copies we need more space in computer its bit costly </a:t>
+              <a:t> we need each copy of that  to monitor the day one works and day2 </a:t>
+            </a:r>
+            <a:r>
+              <a:rPr lang="en-US" dirty="0" err="1"/>
+              <a:t>works.To</a:t>
+            </a:r>
+            <a:r>
+              <a:rPr lang="en-US" dirty="0"/>
+              <a:t> keep copies we need more space in computer its bit costly</a:t>
             </a:r>
           </a:p>
           <a:p>
@@ -3874,7 +4286,7 @@
             </a:br>
             <a:r>
               <a:rPr lang="en-US" dirty="0"/>
-              <a:t>it will monito the day 1 and day 2 of commits</a:t>
+              <a:t>it will monitor the day 1 and day 2 of commits</a:t>
             </a:r>
           </a:p>
           <a:p>
@@ -3882,6 +4294,233 @@
           </a:p>
         </p:txBody>
       </p:sp>
+      <p:graphicFrame>
+        <p:nvGraphicFramePr>
+          <p:cNvPr id="2" name="Table 1">
+            <a:extLst>
+              <a:ext uri="{FF2B5EF4-FFF2-40B4-BE49-F238E27FC236}">
+                <a16:creationId xmlns:a16="http://schemas.microsoft.com/office/drawing/2014/main" id="{E993E271-2A53-A6A3-F60E-F8D388BBE86B}"/>
+              </a:ext>
+            </a:extLst>
+          </p:cNvPr>
+          <p:cNvGraphicFramePr>
+            <a:graphicFrameLocks noGrp="1"/>
+          </p:cNvGraphicFramePr>
+          <p:nvPr>
+            <p:extLst>
+              <p:ext uri="{D42A27DB-BD31-4B8C-83A1-F6EECF244321}">
+                <p14:modId xmlns:p14="http://schemas.microsoft.com/office/powerpoint/2010/main" val="3870764557"/>
+              </p:ext>
+            </p:extLst>
+          </p:nvPr>
+        </p:nvGraphicFramePr>
+        <p:xfrm>
+          <a:off x="6243484" y="3882590"/>
+          <a:ext cx="5873136" cy="2834640"/>
+        </p:xfrm>
+        <a:graphic>
+          <a:graphicData uri="http://schemas.openxmlformats.org/drawingml/2006/table">
+            <a:tbl>
+              <a:tblPr firstRow="1" bandRow="1">
+                <a:tableStyleId>{5C22544A-7EE6-4342-B048-85BDC9FD1C3A}</a:tableStyleId>
+              </a:tblPr>
+              <a:tblGrid>
+                <a:gridCol w="2936568">
+                  <a:extLst>
+                    <a:ext uri="{9D8B030D-6E8A-4147-A177-3AD203B41FA5}">
+                      <a16:colId xmlns:a16="http://schemas.microsoft.com/office/drawing/2014/main" val="3285696878"/>
+                    </a:ext>
+                  </a:extLst>
+                </a:gridCol>
+                <a:gridCol w="2936568">
+                  <a:extLst>
+                    <a:ext uri="{9D8B030D-6E8A-4147-A177-3AD203B41FA5}">
+                      <a16:colId xmlns:a16="http://schemas.microsoft.com/office/drawing/2014/main" val="962816740"/>
+                    </a:ext>
+                  </a:extLst>
+                </a:gridCol>
+              </a:tblGrid>
+              <a:tr h="2562455">
+                <a:tc>
+                  <a:txBody>
+                    <a:bodyPr/>
+                    <a:lstStyle/>
+                    <a:p>
+                      <a:r>
+                        <a:rPr lang="en-US" dirty="0">
+                          <a:solidFill>
+                            <a:schemeClr val="tx1"/>
+                          </a:solidFill>
+                        </a:rPr>
+                        <a:t>Local </a:t>
+                      </a:r>
+                      <a:br>
+                        <a:rPr lang="en-US" dirty="0">
+                          <a:solidFill>
+                            <a:schemeClr val="tx1"/>
+                          </a:solidFill>
+                        </a:rPr>
+                      </a:br>
+                      <a:br>
+                        <a:rPr lang="en-US" dirty="0">
+                          <a:solidFill>
+                            <a:schemeClr val="tx1"/>
+                          </a:solidFill>
+                        </a:rPr>
+                      </a:br>
+                      <a:r>
+                        <a:rPr lang="en-US" dirty="0">
+                          <a:solidFill>
+                            <a:schemeClr val="tx1"/>
+                          </a:solidFill>
+                        </a:rPr>
+                        <a:t>we need </a:t>
+                      </a:r>
+                      <a:r>
+                        <a:rPr lang="en-US" dirty="0" err="1">
+                          <a:solidFill>
+                            <a:schemeClr val="tx1"/>
+                          </a:solidFill>
+                        </a:rPr>
+                        <a:t>seperate</a:t>
+                      </a:r>
+                      <a:r>
+                        <a:rPr lang="en-US" dirty="0">
+                          <a:solidFill>
+                            <a:schemeClr val="tx1"/>
+                          </a:solidFill>
+                        </a:rPr>
+                        <a:t> file to track the status daily</a:t>
+                      </a:r>
+                      <a:br>
+                        <a:rPr lang="en-US" dirty="0">
+                          <a:solidFill>
+                            <a:schemeClr val="tx1"/>
+                          </a:solidFill>
+                        </a:rPr>
+                      </a:br>
+                      <a:br>
+                        <a:rPr lang="en-US" dirty="0">
+                          <a:solidFill>
+                            <a:schemeClr val="tx1"/>
+                          </a:solidFill>
+                        </a:rPr>
+                      </a:br>
+                      <a:r>
+                        <a:rPr lang="en-US" dirty="0">
+                          <a:solidFill>
+                            <a:schemeClr val="tx1"/>
+                          </a:solidFill>
+                        </a:rPr>
+                        <a:t>we can’t able to do that in single file like version control. why because we can’t able to monitor that especially</a:t>
+                      </a:r>
+                      <a:endParaRPr lang="en-IN" dirty="0">
+                        <a:solidFill>
+                          <a:schemeClr val="tx1"/>
+                        </a:solidFill>
+                      </a:endParaRPr>
+                    </a:p>
+                  </a:txBody>
+                  <a:tcPr/>
+                </a:tc>
+                <a:tc>
+                  <a:txBody>
+                    <a:bodyPr/>
+                    <a:lstStyle/>
+                    <a:p>
+                      <a:r>
+                        <a:rPr lang="en-US" dirty="0">
+                          <a:solidFill>
+                            <a:schemeClr val="tx1"/>
+                          </a:solidFill>
+                        </a:rPr>
+                        <a:t>Version control</a:t>
+                      </a:r>
+                      <a:br>
+                        <a:rPr lang="en-US" dirty="0">
+                          <a:solidFill>
+                            <a:schemeClr val="tx1"/>
+                          </a:solidFill>
+                        </a:rPr>
+                      </a:br>
+                      <a:br>
+                        <a:rPr lang="en-US" dirty="0">
+                          <a:solidFill>
+                            <a:schemeClr val="tx1"/>
+                          </a:solidFill>
+                          <a:highlight>
+                            <a:srgbClr val="C0C0C0"/>
+                          </a:highlight>
+                        </a:rPr>
+                      </a:br>
+                      <a:r>
+                        <a:rPr lang="en-US" dirty="0">
+                          <a:solidFill>
+                            <a:schemeClr val="tx1"/>
+                          </a:solidFill>
+                        </a:rPr>
+                        <a:t>here we don’t need to </a:t>
+                      </a:r>
+                    </a:p>
+                    <a:p>
+                      <a:endParaRPr lang="en-US" dirty="0">
+                        <a:solidFill>
+                          <a:schemeClr val="tx1"/>
+                        </a:solidFill>
+                      </a:endParaRPr>
+                    </a:p>
+                    <a:p>
+                      <a:endParaRPr lang="en-US" dirty="0">
+                        <a:solidFill>
+                          <a:schemeClr val="tx1"/>
+                        </a:solidFill>
+                      </a:endParaRPr>
+                    </a:p>
+                    <a:p>
+                      <a:r>
+                        <a:rPr lang="en-US" dirty="0">
+                          <a:solidFill>
+                            <a:schemeClr val="tx1"/>
+                          </a:solidFill>
+                        </a:rPr>
+                        <a:t>Here single file it is enough,</a:t>
+                      </a:r>
+                    </a:p>
+                    <a:p>
+                      <a:r>
+                        <a:rPr lang="en-US" dirty="0">
+                          <a:solidFill>
+                            <a:schemeClr val="tx1"/>
+                          </a:solidFill>
+                        </a:rPr>
+                        <a:t>Monitor the day task also possible.</a:t>
+                      </a:r>
+                      <a:endParaRPr lang="en-IN" dirty="0">
+                        <a:solidFill>
+                          <a:schemeClr val="tx1"/>
+                        </a:solidFill>
+                      </a:endParaRPr>
+                    </a:p>
+                  </a:txBody>
+                  <a:tcPr>
+                    <a:solidFill>
+                      <a:schemeClr val="accent4">
+                        <a:lumMod val="60000"/>
+                        <a:lumOff val="40000"/>
+                      </a:schemeClr>
+                    </a:solidFill>
+                  </a:tcPr>
+                </a:tc>
+                <a:extLst>
+                  <a:ext uri="{0D108BD9-81ED-4DB2-BD59-A6C34878D82A}">
+                    <a16:rowId xmlns:a16="http://schemas.microsoft.com/office/drawing/2014/main" val="3241089609"/>
+                  </a:ext>
+                </a:extLst>
+              </a:tr>
+            </a:tbl>
+          </a:graphicData>
+        </a:graphic>
+      </p:graphicFrame>
     </p:spTree>
     <p:extLst>
       <p:ext uri="{BB962C8B-B14F-4D97-AF65-F5344CB8AC3E}">
@@ -3936,7 +4575,7 @@
         </p:spPr>
         <p:txBody>
           <a:bodyPr>
-            <a:normAutofit fontScale="92500" lnSpcReduction="20000"/>
+            <a:normAutofit fontScale="70000" lnSpcReduction="20000"/>
           </a:bodyPr>
           <a:lstStyle/>
           <a:p>
@@ -3974,7 +4613,7 @@
             </a:r>
             <a:r>
               <a:rPr lang="en-US" dirty="0"/>
-              <a:t>file it means the folder is connected with cloud git from local folders</a:t>
+              <a:t>file in local .It means the folder is connected with cloud git from local folders.</a:t>
             </a:r>
           </a:p>
           <a:p>
@@ -3993,32 +4632,6 @@
             <a:r>
               <a:rPr lang="en-US" dirty="0"/>
               <a:t>And the need configuration if you first time linking</a:t>
-            </a:r>
-          </a:p>
-          <a:p>
-            <a:pPr marL="0" indent="0">
-              <a:buNone/>
-            </a:pPr>
-            <a:r>
-              <a:rPr lang="en-US" dirty="0"/>
-              <a:t>Create folder in local and open the folder in </a:t>
-            </a:r>
-            <a:r>
-              <a:rPr lang="en-US" dirty="0" err="1"/>
-              <a:t>cmd</a:t>
-            </a:r>
-            <a:r>
-              <a:rPr lang="en-US" dirty="0"/>
-              <a:t> </a:t>
-            </a:r>
-          </a:p>
-          <a:p>
-            <a:pPr marL="0" indent="0">
-              <a:buNone/>
-            </a:pPr>
-            <a:r>
-              <a:rPr lang="en-US" dirty="0"/>
-              <a:t>Try git clone it has not cloned means we need to configure</a:t>
             </a:r>
           </a:p>
           <a:p>
@@ -4088,8 +4701,102 @@
               <a:buNone/>
             </a:pPr>
             <a:r>
+              <a:rPr lang="en-US" dirty="0">
+                <a:solidFill>
+                  <a:srgbClr val="FF0000"/>
+                </a:solidFill>
+              </a:rPr>
+              <a:t>Step1</a:t>
+            </a:r>
+            <a:r>
               <a:rPr lang="en-US" dirty="0"/>
-              <a:t>And then git clone to make a copy of the cloud folder or repo </a:t>
+              <a:t>:In </a:t>
+            </a:r>
+            <a:r>
+              <a:rPr lang="en-US" dirty="0" err="1"/>
+              <a:t>Github</a:t>
+            </a:r>
+            <a:r>
+              <a:rPr lang="en-US" dirty="0"/>
+              <a:t> create the branch for projects and then repo (folder name) in </a:t>
+            </a:r>
+            <a:r>
+              <a:rPr lang="en-US" dirty="0">
+                <a:solidFill>
+                  <a:schemeClr val="accent1"/>
+                </a:solidFill>
+              </a:rPr>
+              <a:t>cloud</a:t>
+            </a:r>
+          </a:p>
+          <a:p>
+            <a:pPr marL="0" indent="0">
+              <a:buNone/>
+            </a:pPr>
+            <a:endParaRPr lang="en-US" dirty="0">
+              <a:solidFill>
+                <a:schemeClr val="accent1"/>
+              </a:solidFill>
+            </a:endParaRPr>
+          </a:p>
+          <a:p>
+            <a:pPr marL="0" indent="0">
+              <a:buNone/>
+            </a:pPr>
+            <a:r>
+              <a:rPr lang="en-US" dirty="0">
+                <a:solidFill>
+                  <a:srgbClr val="FF0000"/>
+                </a:solidFill>
+              </a:rPr>
+              <a:t>Step2</a:t>
+            </a:r>
+            <a:r>
+              <a:rPr lang="en-US" dirty="0"/>
+              <a:t>:Create same folder name as repo(cloud) in </a:t>
+            </a:r>
+            <a:r>
+              <a:rPr lang="en-US" dirty="0">
+                <a:solidFill>
+                  <a:schemeClr val="accent2"/>
+                </a:solidFill>
+              </a:rPr>
+              <a:t>local</a:t>
+            </a:r>
+            <a:r>
+              <a:rPr lang="en-US" dirty="0"/>
+              <a:t> and open the folder in </a:t>
+            </a:r>
+            <a:r>
+              <a:rPr lang="en-US" dirty="0" err="1"/>
+              <a:t>cmd</a:t>
+            </a:r>
+            <a:r>
+              <a:rPr lang="en-US" dirty="0"/>
+              <a:t> </a:t>
+            </a:r>
+          </a:p>
+          <a:p>
+            <a:pPr marL="0" indent="0">
+              <a:buNone/>
+            </a:pPr>
+            <a:endParaRPr lang="en-US" dirty="0"/>
+          </a:p>
+          <a:p>
+            <a:pPr marL="0" indent="0">
+              <a:buNone/>
+            </a:pPr>
+            <a:r>
+              <a:rPr lang="en-US" dirty="0">
+                <a:solidFill>
+                  <a:srgbClr val="FF0000"/>
+                </a:solidFill>
+              </a:rPr>
+              <a:t>Step3</a:t>
+            </a:r>
+            <a:r>
+              <a:rPr lang="en-US" dirty="0"/>
+              <a:t>:And then git clone to make a copy of the cloud folder or repo to local</a:t>
             </a:r>
           </a:p>
           <a:p>
@@ -4127,8 +4834,17 @@
                   <a:srgbClr val="0070C0"/>
                 </a:solidFill>
               </a:rPr>
-              <a:t>”</a:t>
-            </a:r>
+              <a:t>”        </a:t>
+            </a:r>
+            <a:r>
+              <a:rPr lang="en-US" sz="2900" dirty="0"/>
+              <a:t>---if use for one project it is enough  </a:t>
+            </a:r>
+            <a:endParaRPr lang="en-US" dirty="0">
+              <a:solidFill>
+                <a:srgbClr val="0070C0"/>
+              </a:solidFill>
+            </a:endParaRPr>
           </a:p>
           <a:p>
             <a:pPr marL="0" indent="0">
@@ -4189,7 +4905,11 @@
                   <a:srgbClr val="0070C0"/>
                 </a:solidFill>
               </a:rPr>
-              <a:t>”</a:t>
+              <a:t>”  </a:t>
+            </a:r>
+            <a:r>
+              <a:rPr lang="en-US" dirty="0"/>
+              <a:t>--- if use for multiple project</a:t>
             </a:r>
           </a:p>
           <a:p>
@@ -4386,7 +5106,7 @@
         </p:blipFill>
         <p:spPr>
           <a:xfrm>
-            <a:off x="347648" y="160783"/>
+            <a:off x="267081" y="206112"/>
             <a:ext cx="3877216" cy="2057687"/>
           </a:xfrm>
         </p:spPr>
@@ -4457,8 +5177,8 @@
         </p:nvSpPr>
         <p:spPr>
           <a:xfrm>
-            <a:off x="4345858" y="235974"/>
-            <a:ext cx="7246374" cy="646331"/>
+            <a:off x="4343951" y="133335"/>
+            <a:ext cx="7246374" cy="2308324"/>
           </a:xfrm>
           <a:prstGeom prst="rect">
             <a:avLst/>
@@ -4472,12 +5192,679 @@
           <a:lstStyle/>
           <a:p>
             <a:r>
+              <a:rPr lang="en-US" dirty="0">
+                <a:solidFill>
+                  <a:srgbClr val="FF0000"/>
+                </a:solidFill>
+              </a:rPr>
+              <a:t>Step4: </a:t>
+            </a:r>
+            <a:r>
               <a:rPr lang="en-US" dirty="0"/>
-              <a:t>U-untracked what does it mean</a:t>
+              <a:t>create files </a:t>
+            </a:r>
+            <a:r>
+              <a:rPr lang="en-US" dirty="0" err="1"/>
+              <a:t>eg</a:t>
+            </a:r>
+            <a:r>
+              <a:rPr lang="en-US" dirty="0"/>
+              <a:t>: myself created </a:t>
+            </a:r>
+            <a:r>
+              <a:rPr lang="en-US" dirty="0">
+                <a:solidFill>
+                  <a:srgbClr val="FF0000"/>
+                </a:solidFill>
+              </a:rPr>
+              <a:t>file1.txt</a:t>
+            </a:r>
+          </a:p>
+          <a:p>
+            <a:endParaRPr lang="en-US" dirty="0"/>
+          </a:p>
+          <a:p>
+            <a:r>
+              <a:rPr lang="en-US" dirty="0"/>
+              <a:t>U-untracked what does it mean not staged </a:t>
+            </a:r>
+          </a:p>
+          <a:p>
+            <a:br>
+              <a:rPr lang="en-US" dirty="0"/>
+            </a:br>
+            <a:r>
+              <a:rPr lang="en-US" dirty="0"/>
+              <a:t>"Untracked" refers to files that are not being tracked by the version control system. These files are new and haven't been added to the staging area or committed to the repository.</a:t>
             </a:r>
           </a:p>
           <a:p>
             <a:endParaRPr lang="en-IN" dirty="0"/>
+          </a:p>
+        </p:txBody>
+      </p:sp>
+      <p:pic>
+        <p:nvPicPr>
+          <p:cNvPr id="3" name="Picture 2">
+            <a:extLst>
+              <a:ext uri="{FF2B5EF4-FFF2-40B4-BE49-F238E27FC236}">
+                <a16:creationId xmlns:a16="http://schemas.microsoft.com/office/drawing/2014/main" id="{28634032-8D48-52A0-FDC3-40B26BF2A61A}"/>
+              </a:ext>
+            </a:extLst>
+          </p:cNvPr>
+          <p:cNvPicPr>
+            <a:picLocks noChangeAspect="1"/>
+          </p:cNvPicPr>
+          <p:nvPr/>
+        </p:nvPicPr>
+        <p:blipFill>
+          <a:blip r:embed="rId3"/>
+          <a:stretch>
+            <a:fillRect/>
+          </a:stretch>
+        </p:blipFill>
+        <p:spPr>
+          <a:xfrm>
+            <a:off x="347648" y="2493278"/>
+            <a:ext cx="3134162" cy="1733792"/>
+          </a:xfrm>
+          <a:prstGeom prst="rect">
+            <a:avLst/>
+          </a:prstGeom>
+        </p:spPr>
+      </p:pic>
+      <p:pic>
+        <p:nvPicPr>
+          <p:cNvPr id="8" name="Picture 7">
+            <a:extLst>
+              <a:ext uri="{FF2B5EF4-FFF2-40B4-BE49-F238E27FC236}">
+                <a16:creationId xmlns:a16="http://schemas.microsoft.com/office/drawing/2014/main" id="{74CD6851-2C7C-D541-80F7-11D06E2BC167}"/>
+              </a:ext>
+            </a:extLst>
+          </p:cNvPr>
+          <p:cNvPicPr>
+            <a:picLocks noChangeAspect="1"/>
+          </p:cNvPicPr>
+          <p:nvPr/>
+        </p:nvPicPr>
+        <p:blipFill>
+          <a:blip r:embed="rId4"/>
+          <a:stretch>
+            <a:fillRect/>
+          </a:stretch>
+        </p:blipFill>
+        <p:spPr>
+          <a:xfrm>
+            <a:off x="372485" y="4501878"/>
+            <a:ext cx="3448531" cy="2095792"/>
+          </a:xfrm>
+          <a:prstGeom prst="rect">
+            <a:avLst/>
+          </a:prstGeom>
+        </p:spPr>
+      </p:pic>
+      <p:pic>
+        <p:nvPicPr>
+          <p:cNvPr id="10" name="Picture 9">
+            <a:extLst>
+              <a:ext uri="{FF2B5EF4-FFF2-40B4-BE49-F238E27FC236}">
+                <a16:creationId xmlns:a16="http://schemas.microsoft.com/office/drawing/2014/main" id="{C97B2A42-76DB-BC5D-1F2D-98E95250C419}"/>
+              </a:ext>
+            </a:extLst>
+          </p:cNvPr>
+          <p:cNvPicPr>
+            <a:picLocks noChangeAspect="1"/>
+          </p:cNvPicPr>
+          <p:nvPr/>
+        </p:nvPicPr>
+        <p:blipFill>
+          <a:blip r:embed="rId5"/>
+          <a:stretch>
+            <a:fillRect/>
+          </a:stretch>
+        </p:blipFill>
+        <p:spPr>
+          <a:xfrm>
+            <a:off x="8029057" y="2277557"/>
+            <a:ext cx="3658111" cy="1524213"/>
+          </a:xfrm>
+          <a:prstGeom prst="rect">
+            <a:avLst/>
+          </a:prstGeom>
+        </p:spPr>
+      </p:pic>
+      <p:sp>
+        <p:nvSpPr>
+          <p:cNvPr id="17" name="TextBox 16">
+            <a:extLst>
+              <a:ext uri="{FF2B5EF4-FFF2-40B4-BE49-F238E27FC236}">
+                <a16:creationId xmlns:a16="http://schemas.microsoft.com/office/drawing/2014/main" id="{D3257AA3-1953-8661-A09B-1D5DDF40942F}"/>
+              </a:ext>
+            </a:extLst>
+          </p:cNvPr>
+          <p:cNvSpPr txBox="1"/>
+          <p:nvPr/>
+        </p:nvSpPr>
+        <p:spPr>
+          <a:xfrm>
+            <a:off x="4001729" y="2582263"/>
+            <a:ext cx="3421626" cy="1200329"/>
+          </a:xfrm>
+          <a:prstGeom prst="rect">
+            <a:avLst/>
+          </a:prstGeom>
+          <a:noFill/>
+        </p:spPr>
+        <p:txBody>
+          <a:bodyPr wrap="square" rtlCol="0">
+            <a:spAutoFit/>
+          </a:bodyPr>
+          <a:lstStyle/>
+          <a:p>
+            <a:r>
+              <a:rPr lang="en-US" dirty="0">
+                <a:solidFill>
+                  <a:srgbClr val="FF0000"/>
+                </a:solidFill>
+              </a:rPr>
+              <a:t>Step5</a:t>
+            </a:r>
+            <a:r>
+              <a:rPr lang="en-US" dirty="0"/>
+              <a:t>: </a:t>
+            </a:r>
+            <a:r>
+              <a:rPr lang="en-US" dirty="0">
+                <a:solidFill>
+                  <a:srgbClr val="FF0000"/>
+                </a:solidFill>
+              </a:rPr>
+              <a:t>Staging</a:t>
+            </a:r>
+            <a:r>
+              <a:rPr lang="en-US" dirty="0"/>
+              <a:t> should be done.</a:t>
+            </a:r>
+            <a:br>
+              <a:rPr lang="en-US" dirty="0"/>
+            </a:br>
+            <a:r>
+              <a:rPr lang="en-US" dirty="0"/>
+              <a:t>file1.txt was created in local and added some content &amp; saved that content.</a:t>
+            </a:r>
+            <a:endParaRPr lang="en-IN" dirty="0"/>
+          </a:p>
+        </p:txBody>
+      </p:sp>
+      <p:sp>
+        <p:nvSpPr>
+          <p:cNvPr id="19" name="TextBox 18">
+            <a:extLst>
+              <a:ext uri="{FF2B5EF4-FFF2-40B4-BE49-F238E27FC236}">
+                <a16:creationId xmlns:a16="http://schemas.microsoft.com/office/drawing/2014/main" id="{F262792A-21D1-0F71-A53F-5305AF1C0B35}"/>
+              </a:ext>
+            </a:extLst>
+          </p:cNvPr>
+          <p:cNvSpPr txBox="1"/>
+          <p:nvPr/>
+        </p:nvSpPr>
+        <p:spPr>
+          <a:xfrm>
+            <a:off x="4956987" y="6147822"/>
+            <a:ext cx="6617110" cy="369332"/>
+          </a:xfrm>
+          <a:prstGeom prst="rect">
+            <a:avLst/>
+          </a:prstGeom>
+          <a:noFill/>
+        </p:spPr>
+        <p:txBody>
+          <a:bodyPr wrap="square">
+            <a:spAutoFit/>
+          </a:bodyPr>
+          <a:lstStyle/>
+          <a:p>
+            <a:r>
+              <a:rPr lang="en-US" b="1" dirty="0">
+                <a:solidFill>
+                  <a:srgbClr val="FF0000"/>
+                </a:solidFill>
+              </a:rPr>
+              <a:t>Goal</a:t>
+            </a:r>
+            <a:r>
+              <a:rPr lang="en-US" dirty="0"/>
+              <a:t>: local saved content transfer to cloud git. Follow the step 5 ,7)</a:t>
+            </a:r>
+            <a:endParaRPr lang="en-IN" dirty="0"/>
+          </a:p>
+        </p:txBody>
+      </p:sp>
+      <p:sp>
+        <p:nvSpPr>
+          <p:cNvPr id="20" name="TextBox 19">
+            <a:extLst>
+              <a:ext uri="{FF2B5EF4-FFF2-40B4-BE49-F238E27FC236}">
+                <a16:creationId xmlns:a16="http://schemas.microsoft.com/office/drawing/2014/main" id="{FE42BBC5-84D2-365F-808B-8E69341AF498}"/>
+              </a:ext>
+            </a:extLst>
+          </p:cNvPr>
+          <p:cNvSpPr txBox="1"/>
+          <p:nvPr/>
+        </p:nvSpPr>
+        <p:spPr>
+          <a:xfrm>
+            <a:off x="4212021" y="4444754"/>
+            <a:ext cx="3603522" cy="1200329"/>
+          </a:xfrm>
+          <a:prstGeom prst="rect">
+            <a:avLst/>
+          </a:prstGeom>
+          <a:noFill/>
+        </p:spPr>
+        <p:txBody>
+          <a:bodyPr wrap="square" rtlCol="0">
+            <a:spAutoFit/>
+          </a:bodyPr>
+          <a:lstStyle/>
+          <a:p>
+            <a:r>
+              <a:rPr lang="en-US" dirty="0">
+                <a:solidFill>
+                  <a:srgbClr val="FF0000"/>
+                </a:solidFill>
+              </a:rPr>
+              <a:t>Step6</a:t>
+            </a:r>
+            <a:r>
+              <a:rPr lang="en-US" dirty="0"/>
+              <a:t>: </a:t>
+            </a:r>
+            <a:r>
+              <a:rPr lang="en-US" dirty="0" err="1">
+                <a:solidFill>
+                  <a:srgbClr val="FF0000"/>
+                </a:solidFill>
+              </a:rPr>
+              <a:t>Unstaging</a:t>
+            </a:r>
+            <a:r>
+              <a:rPr lang="en-US" dirty="0">
+                <a:solidFill>
+                  <a:srgbClr val="FF0000"/>
+                </a:solidFill>
+              </a:rPr>
+              <a:t> what for </a:t>
+            </a:r>
+            <a:br>
+              <a:rPr lang="en-US" dirty="0"/>
+            </a:br>
+            <a:r>
+              <a:rPr lang="en-US" dirty="0"/>
+              <a:t>unnecessary edits ,not to be reflect in the cloud git </a:t>
+            </a:r>
+          </a:p>
+          <a:p>
+            <a:r>
+              <a:rPr lang="en-US" dirty="0"/>
+              <a:t>so we </a:t>
+            </a:r>
+            <a:r>
+              <a:rPr lang="en-US" dirty="0" err="1"/>
+              <a:t>unstage</a:t>
+            </a:r>
+            <a:r>
+              <a:rPr lang="en-US" dirty="0"/>
+              <a:t> ,the staged  changes </a:t>
+            </a:r>
+            <a:endParaRPr lang="en-IN" dirty="0"/>
+          </a:p>
+        </p:txBody>
+      </p:sp>
+      <p:sp>
+        <p:nvSpPr>
+          <p:cNvPr id="21" name="TextBox 20">
+            <a:extLst>
+              <a:ext uri="{FF2B5EF4-FFF2-40B4-BE49-F238E27FC236}">
+                <a16:creationId xmlns:a16="http://schemas.microsoft.com/office/drawing/2014/main" id="{36FF75D9-72A3-B6CA-3F62-5C24A41A8304}"/>
+              </a:ext>
+            </a:extLst>
+          </p:cNvPr>
+          <p:cNvSpPr txBox="1"/>
+          <p:nvPr/>
+        </p:nvSpPr>
+        <p:spPr>
+          <a:xfrm>
+            <a:off x="8265542" y="4227070"/>
+            <a:ext cx="3658110" cy="1477328"/>
+          </a:xfrm>
+          <a:prstGeom prst="rect">
+            <a:avLst/>
+          </a:prstGeom>
+          <a:noFill/>
+        </p:spPr>
+        <p:txBody>
+          <a:bodyPr wrap="square" rtlCol="0">
+            <a:spAutoFit/>
+          </a:bodyPr>
+          <a:lstStyle/>
+          <a:p>
+            <a:r>
+              <a:rPr lang="en-US" dirty="0">
+                <a:solidFill>
+                  <a:srgbClr val="FF0000"/>
+                </a:solidFill>
+              </a:rPr>
+              <a:t>Step7</a:t>
+            </a:r>
+            <a:r>
+              <a:rPr lang="en-US" dirty="0"/>
+              <a:t>: Staged changes only allowed for commits.</a:t>
+            </a:r>
+          </a:p>
+          <a:p>
+            <a:r>
+              <a:rPr lang="en-US" dirty="0"/>
+              <a:t>The box shows the </a:t>
+            </a:r>
+            <a:r>
+              <a:rPr lang="en-US" dirty="0">
+                <a:solidFill>
+                  <a:schemeClr val="accent6"/>
+                </a:solidFill>
+              </a:rPr>
+              <a:t>commit Message</a:t>
+            </a:r>
+            <a:br>
+              <a:rPr lang="en-US" dirty="0"/>
+            </a:br>
+            <a:r>
+              <a:rPr lang="en-US" dirty="0"/>
+              <a:t>after commit ,</a:t>
+            </a:r>
+            <a:r>
+              <a:rPr lang="en-US" dirty="0">
+                <a:solidFill>
+                  <a:srgbClr val="FF0000"/>
+                </a:solidFill>
+              </a:rPr>
+              <a:t>push</a:t>
+            </a:r>
+            <a:r>
+              <a:rPr lang="en-US" dirty="0"/>
+              <a:t> can be done in different ways in vs code.</a:t>
+            </a:r>
+            <a:endParaRPr lang="en-IN" dirty="0"/>
+          </a:p>
+        </p:txBody>
+      </p:sp>
+      <p:cxnSp>
+        <p:nvCxnSpPr>
+          <p:cNvPr id="23" name="Straight Arrow Connector 22">
+            <a:extLst>
+              <a:ext uri="{FF2B5EF4-FFF2-40B4-BE49-F238E27FC236}">
+                <a16:creationId xmlns:a16="http://schemas.microsoft.com/office/drawing/2014/main" id="{E0158D10-169D-D704-9B6F-B6360694EBF7}"/>
+              </a:ext>
+            </a:extLst>
+          </p:cNvPr>
+          <p:cNvCxnSpPr>
+            <a:stCxn id="10" idx="2"/>
+          </p:cNvCxnSpPr>
+          <p:nvPr/>
+        </p:nvCxnSpPr>
+        <p:spPr>
+          <a:xfrm flipH="1">
+            <a:off x="9858112" y="3801770"/>
+            <a:ext cx="1" cy="401802"/>
+          </a:xfrm>
+          <a:prstGeom prst="straightConnector1">
+            <a:avLst/>
+          </a:prstGeom>
+          <a:ln>
+            <a:solidFill>
+              <a:srgbClr val="FF0000"/>
+            </a:solidFill>
+            <a:tailEnd type="triangle"/>
+          </a:ln>
+        </p:spPr>
+        <p:style>
+          <a:lnRef idx="1">
+            <a:schemeClr val="accent1"/>
+          </a:lnRef>
+          <a:fillRef idx="0">
+            <a:schemeClr val="accent1"/>
+          </a:fillRef>
+          <a:effectRef idx="0">
+            <a:schemeClr val="accent1"/>
+          </a:effectRef>
+          <a:fontRef idx="minor">
+            <a:schemeClr val="tx1"/>
+          </a:fontRef>
+        </p:style>
+      </p:cxnSp>
+      <p:cxnSp>
+        <p:nvCxnSpPr>
+          <p:cNvPr id="25" name="Straight Arrow Connector 24">
+            <a:extLst>
+              <a:ext uri="{FF2B5EF4-FFF2-40B4-BE49-F238E27FC236}">
+                <a16:creationId xmlns:a16="http://schemas.microsoft.com/office/drawing/2014/main" id="{E7EDCEB8-0280-A3EE-256D-855EE45D809C}"/>
+              </a:ext>
+            </a:extLst>
+          </p:cNvPr>
+          <p:cNvCxnSpPr>
+            <a:stCxn id="3" idx="3"/>
+          </p:cNvCxnSpPr>
+          <p:nvPr/>
+        </p:nvCxnSpPr>
+        <p:spPr>
+          <a:xfrm flipV="1">
+            <a:off x="3481810" y="3342968"/>
+            <a:ext cx="519919" cy="17206"/>
+          </a:xfrm>
+          <a:prstGeom prst="straightConnector1">
+            <a:avLst/>
+          </a:prstGeom>
+          <a:ln>
+            <a:solidFill>
+              <a:srgbClr val="FF0000"/>
+            </a:solidFill>
+            <a:tailEnd type="triangle"/>
+          </a:ln>
+        </p:spPr>
+        <p:style>
+          <a:lnRef idx="1">
+            <a:schemeClr val="accent1"/>
+          </a:lnRef>
+          <a:fillRef idx="0">
+            <a:schemeClr val="accent1"/>
+          </a:fillRef>
+          <a:effectRef idx="0">
+            <a:schemeClr val="accent1"/>
+          </a:effectRef>
+          <a:fontRef idx="minor">
+            <a:schemeClr val="tx1"/>
+          </a:fontRef>
+        </p:style>
+      </p:cxnSp>
+      <p:cxnSp>
+        <p:nvCxnSpPr>
+          <p:cNvPr id="27" name="Straight Arrow Connector 26">
+            <a:extLst>
+              <a:ext uri="{FF2B5EF4-FFF2-40B4-BE49-F238E27FC236}">
+                <a16:creationId xmlns:a16="http://schemas.microsoft.com/office/drawing/2014/main" id="{42E9D90C-0A41-2A34-6AC3-169E8E425008}"/>
+              </a:ext>
+            </a:extLst>
+          </p:cNvPr>
+          <p:cNvCxnSpPr>
+            <a:stCxn id="8" idx="3"/>
+          </p:cNvCxnSpPr>
+          <p:nvPr/>
+        </p:nvCxnSpPr>
+        <p:spPr>
+          <a:xfrm flipV="1">
+            <a:off x="3821016" y="5518512"/>
+            <a:ext cx="323281" cy="31262"/>
+          </a:xfrm>
+          <a:prstGeom prst="straightConnector1">
+            <a:avLst/>
+          </a:prstGeom>
+          <a:ln>
+            <a:solidFill>
+              <a:srgbClr val="FF0000"/>
+            </a:solidFill>
+            <a:tailEnd type="triangle"/>
+          </a:ln>
+        </p:spPr>
+        <p:style>
+          <a:lnRef idx="1">
+            <a:schemeClr val="accent1"/>
+          </a:lnRef>
+          <a:fillRef idx="0">
+            <a:schemeClr val="accent1"/>
+          </a:fillRef>
+          <a:effectRef idx="0">
+            <a:schemeClr val="accent1"/>
+          </a:effectRef>
+          <a:fontRef idx="minor">
+            <a:schemeClr val="tx1"/>
+          </a:fontRef>
+        </p:style>
+      </p:cxnSp>
+      <p:cxnSp>
+        <p:nvCxnSpPr>
+          <p:cNvPr id="29" name="Straight Arrow Connector 28">
+            <a:extLst>
+              <a:ext uri="{FF2B5EF4-FFF2-40B4-BE49-F238E27FC236}">
+                <a16:creationId xmlns:a16="http://schemas.microsoft.com/office/drawing/2014/main" id="{476EC931-4039-E3FC-0729-8BAB7FED8B27}"/>
+              </a:ext>
+            </a:extLst>
+          </p:cNvPr>
+          <p:cNvCxnSpPr/>
+          <p:nvPr/>
+        </p:nvCxnSpPr>
+        <p:spPr>
+          <a:xfrm>
+            <a:off x="4247108" y="1184630"/>
+            <a:ext cx="246234" cy="0"/>
+          </a:xfrm>
+          <a:prstGeom prst="straightConnector1">
+            <a:avLst/>
+          </a:prstGeom>
+          <a:ln>
+            <a:solidFill>
+              <a:srgbClr val="FF0000"/>
+            </a:solidFill>
+            <a:tailEnd type="triangle"/>
+          </a:ln>
+        </p:spPr>
+        <p:style>
+          <a:lnRef idx="1">
+            <a:schemeClr val="accent1"/>
+          </a:lnRef>
+          <a:fillRef idx="0">
+            <a:schemeClr val="accent1"/>
+          </a:fillRef>
+          <a:effectRef idx="0">
+            <a:schemeClr val="accent1"/>
+          </a:effectRef>
+          <a:fontRef idx="minor">
+            <a:schemeClr val="tx1"/>
+          </a:fontRef>
+        </p:style>
+      </p:cxnSp>
+      <p:sp>
+        <p:nvSpPr>
+          <p:cNvPr id="30" name="Rectangle 29">
+            <a:extLst>
+              <a:ext uri="{FF2B5EF4-FFF2-40B4-BE49-F238E27FC236}">
+                <a16:creationId xmlns:a16="http://schemas.microsoft.com/office/drawing/2014/main" id="{5EDE15C1-9B4A-6D6D-6832-F7DE9F7CEC67}"/>
+              </a:ext>
+            </a:extLst>
+          </p:cNvPr>
+          <p:cNvSpPr/>
+          <p:nvPr/>
+        </p:nvSpPr>
+        <p:spPr>
+          <a:xfrm>
+            <a:off x="8265542" y="2674374"/>
+            <a:ext cx="2028832" cy="314632"/>
+          </a:xfrm>
+          <a:prstGeom prst="rect">
+            <a:avLst/>
+          </a:prstGeom>
+          <a:noFill/>
+          <a:ln w="19050">
+            <a:solidFill>
+              <a:srgbClr val="FF0000"/>
+            </a:solidFill>
+          </a:ln>
+        </p:spPr>
+        <p:style>
+          <a:lnRef idx="2">
+            <a:schemeClr val="accent1">
+              <a:shade val="15000"/>
+            </a:schemeClr>
+          </a:lnRef>
+          <a:fillRef idx="1">
+            <a:schemeClr val="accent1"/>
+          </a:fillRef>
+          <a:effectRef idx="0">
+            <a:schemeClr val="accent1"/>
+          </a:effectRef>
+          <a:fontRef idx="minor">
+            <a:schemeClr val="lt1"/>
+          </a:fontRef>
+        </p:style>
+        <p:txBody>
+          <a:bodyPr rtlCol="0" anchor="ctr"/>
+          <a:lstStyle/>
+          <a:p>
+            <a:pPr algn="ctr"/>
+            <a:endParaRPr lang="en-IN"/>
+          </a:p>
+        </p:txBody>
+      </p:sp>
+      <p:sp>
+        <p:nvSpPr>
+          <p:cNvPr id="31" name="TextBox 30">
+            <a:extLst>
+              <a:ext uri="{FF2B5EF4-FFF2-40B4-BE49-F238E27FC236}">
+                <a16:creationId xmlns:a16="http://schemas.microsoft.com/office/drawing/2014/main" id="{9C2803C0-E563-990C-815C-A352930428DA}"/>
+              </a:ext>
+            </a:extLst>
+          </p:cNvPr>
+          <p:cNvSpPr txBox="1"/>
+          <p:nvPr/>
+        </p:nvSpPr>
+        <p:spPr>
+          <a:xfrm>
+            <a:off x="4956987" y="6434798"/>
+            <a:ext cx="3421626" cy="369332"/>
+          </a:xfrm>
+          <a:prstGeom prst="rect">
+            <a:avLst/>
+          </a:prstGeom>
+          <a:noFill/>
+        </p:spPr>
+        <p:txBody>
+          <a:bodyPr wrap="square" rtlCol="0">
+            <a:spAutoFit/>
+          </a:bodyPr>
+          <a:lstStyle/>
+          <a:p>
+            <a:r>
+              <a:rPr lang="en-US" dirty="0">
+                <a:solidFill>
+                  <a:srgbClr val="7030A0"/>
+                </a:solidFill>
+              </a:rPr>
+              <a:t>Detailed explanation in draw.io file</a:t>
+            </a:r>
+            <a:endParaRPr lang="en-IN" dirty="0">
+              <a:solidFill>
+                <a:srgbClr val="7030A0"/>
+              </a:solidFill>
+            </a:endParaRPr>
           </a:p>
         </p:txBody>
       </p:sp>
@@ -4513,6 +5900,485 @@
       </p:grpSpPr>
       <p:sp>
         <p:nvSpPr>
+          <p:cNvPr id="3" name="Content Placeholder 2">
+            <a:extLst>
+              <a:ext uri="{FF2B5EF4-FFF2-40B4-BE49-F238E27FC236}">
+                <a16:creationId xmlns:a16="http://schemas.microsoft.com/office/drawing/2014/main" id="{824BA676-AE22-3BEE-1F22-2D0057EA07C5}"/>
+              </a:ext>
+            </a:extLst>
+          </p:cNvPr>
+          <p:cNvSpPr>
+            <a:spLocks noGrp="1"/>
+          </p:cNvSpPr>
+          <p:nvPr>
+            <p:ph idx="1"/>
+          </p:nvPr>
+        </p:nvSpPr>
+        <p:spPr>
+          <a:xfrm>
+            <a:off x="314632" y="235974"/>
+            <a:ext cx="11788878" cy="6371303"/>
+          </a:xfrm>
+        </p:spPr>
+        <p:txBody>
+          <a:bodyPr/>
+          <a:lstStyle/>
+          <a:p>
+            <a:pPr marL="0" indent="0">
+              <a:buNone/>
+            </a:pPr>
+            <a:endParaRPr lang="en-IN" dirty="0"/>
+          </a:p>
+        </p:txBody>
+      </p:sp>
+      <p:pic>
+        <p:nvPicPr>
+          <p:cNvPr id="16" name="Picture 15">
+            <a:extLst>
+              <a:ext uri="{FF2B5EF4-FFF2-40B4-BE49-F238E27FC236}">
+                <a16:creationId xmlns:a16="http://schemas.microsoft.com/office/drawing/2014/main" id="{BE6B2E5A-0236-9FC6-5328-D698F922B9B2}"/>
+              </a:ext>
+            </a:extLst>
+          </p:cNvPr>
+          <p:cNvPicPr>
+            <a:picLocks noChangeAspect="1"/>
+          </p:cNvPicPr>
+          <p:nvPr/>
+        </p:nvPicPr>
+        <p:blipFill>
+          <a:blip r:embed="rId2"/>
+          <a:stretch>
+            <a:fillRect/>
+          </a:stretch>
+        </p:blipFill>
+        <p:spPr>
+          <a:xfrm>
+            <a:off x="658761" y="3954099"/>
+            <a:ext cx="5172797" cy="2210108"/>
+          </a:xfrm>
+          <a:prstGeom prst="rect">
+            <a:avLst/>
+          </a:prstGeom>
+        </p:spPr>
+      </p:pic>
+      <p:pic>
+        <p:nvPicPr>
+          <p:cNvPr id="12" name="Picture 11">
+            <a:extLst>
+              <a:ext uri="{FF2B5EF4-FFF2-40B4-BE49-F238E27FC236}">
+                <a16:creationId xmlns:a16="http://schemas.microsoft.com/office/drawing/2014/main" id="{7792775A-B5D8-56D4-AB90-B11493863308}"/>
+              </a:ext>
+            </a:extLst>
+          </p:cNvPr>
+          <p:cNvPicPr>
+            <a:picLocks noChangeAspect="1"/>
+          </p:cNvPicPr>
+          <p:nvPr/>
+        </p:nvPicPr>
+        <p:blipFill>
+          <a:blip r:embed="rId3"/>
+          <a:stretch>
+            <a:fillRect/>
+          </a:stretch>
+        </p:blipFill>
+        <p:spPr>
+          <a:xfrm>
+            <a:off x="6990598" y="490061"/>
+            <a:ext cx="4886770" cy="2850616"/>
+          </a:xfrm>
+          <a:prstGeom prst="rect">
+            <a:avLst/>
+          </a:prstGeom>
+        </p:spPr>
+      </p:pic>
+      <p:pic>
+        <p:nvPicPr>
+          <p:cNvPr id="14" name="Picture 13">
+            <a:extLst>
+              <a:ext uri="{FF2B5EF4-FFF2-40B4-BE49-F238E27FC236}">
+                <a16:creationId xmlns:a16="http://schemas.microsoft.com/office/drawing/2014/main" id="{E81A80EB-BBBF-7D19-CE94-74DBC6D4A4DE}"/>
+              </a:ext>
+            </a:extLst>
+          </p:cNvPr>
+          <p:cNvPicPr>
+            <a:picLocks noChangeAspect="1"/>
+          </p:cNvPicPr>
+          <p:nvPr/>
+        </p:nvPicPr>
+        <p:blipFill>
+          <a:blip r:embed="rId4"/>
+          <a:stretch>
+            <a:fillRect/>
+          </a:stretch>
+        </p:blipFill>
+        <p:spPr>
+          <a:xfrm>
+            <a:off x="434526" y="319709"/>
+            <a:ext cx="3658111" cy="3191320"/>
+          </a:xfrm>
+          <a:prstGeom prst="rect">
+            <a:avLst/>
+          </a:prstGeom>
+        </p:spPr>
+      </p:pic>
+      <p:cxnSp>
+        <p:nvCxnSpPr>
+          <p:cNvPr id="5" name="Straight Arrow Connector 4">
+            <a:extLst>
+              <a:ext uri="{FF2B5EF4-FFF2-40B4-BE49-F238E27FC236}">
+                <a16:creationId xmlns:a16="http://schemas.microsoft.com/office/drawing/2014/main" id="{58D7DCD3-CB99-195E-C130-8BEB431D7319}"/>
+              </a:ext>
+            </a:extLst>
+          </p:cNvPr>
+          <p:cNvCxnSpPr/>
+          <p:nvPr/>
+        </p:nvCxnSpPr>
+        <p:spPr>
+          <a:xfrm>
+            <a:off x="3795252" y="1042219"/>
+            <a:ext cx="1297858" cy="442452"/>
+          </a:xfrm>
+          <a:prstGeom prst="straightConnector1">
+            <a:avLst/>
+          </a:prstGeom>
+          <a:ln>
+            <a:tailEnd type="triangle"/>
+          </a:ln>
+        </p:spPr>
+        <p:style>
+          <a:lnRef idx="1">
+            <a:schemeClr val="accent1"/>
+          </a:lnRef>
+          <a:fillRef idx="0">
+            <a:schemeClr val="accent1"/>
+          </a:fillRef>
+          <a:effectRef idx="0">
+            <a:schemeClr val="accent1"/>
+          </a:effectRef>
+          <a:fontRef idx="minor">
+            <a:schemeClr val="tx1"/>
+          </a:fontRef>
+        </p:style>
+      </p:cxnSp>
+      <p:cxnSp>
+        <p:nvCxnSpPr>
+          <p:cNvPr id="7" name="Straight Arrow Connector 6">
+            <a:extLst>
+              <a:ext uri="{FF2B5EF4-FFF2-40B4-BE49-F238E27FC236}">
+                <a16:creationId xmlns:a16="http://schemas.microsoft.com/office/drawing/2014/main" id="{0F23AC65-702A-2CAC-A6D9-2E69D88ABC70}"/>
+              </a:ext>
+            </a:extLst>
+          </p:cNvPr>
+          <p:cNvCxnSpPr/>
+          <p:nvPr/>
+        </p:nvCxnSpPr>
+        <p:spPr>
+          <a:xfrm flipH="1">
+            <a:off x="6209071" y="1042219"/>
+            <a:ext cx="1745226" cy="530942"/>
+          </a:xfrm>
+          <a:prstGeom prst="straightConnector1">
+            <a:avLst/>
+          </a:prstGeom>
+          <a:ln>
+            <a:tailEnd type="triangle"/>
+          </a:ln>
+        </p:spPr>
+        <p:style>
+          <a:lnRef idx="1">
+            <a:schemeClr val="accent1"/>
+          </a:lnRef>
+          <a:fillRef idx="0">
+            <a:schemeClr val="accent1"/>
+          </a:fillRef>
+          <a:effectRef idx="0">
+            <a:schemeClr val="accent1"/>
+          </a:effectRef>
+          <a:fontRef idx="minor">
+            <a:schemeClr val="tx1"/>
+          </a:fontRef>
+        </p:style>
+      </p:cxnSp>
+      <p:sp>
+        <p:nvSpPr>
+          <p:cNvPr id="9" name="TextBox 8">
+            <a:extLst>
+              <a:ext uri="{FF2B5EF4-FFF2-40B4-BE49-F238E27FC236}">
+                <a16:creationId xmlns:a16="http://schemas.microsoft.com/office/drawing/2014/main" id="{B750120B-9D7A-8A1E-71BE-077F5F79F6D4}"/>
+              </a:ext>
+            </a:extLst>
+          </p:cNvPr>
+          <p:cNvSpPr txBox="1"/>
+          <p:nvPr/>
+        </p:nvSpPr>
+        <p:spPr>
+          <a:xfrm>
+            <a:off x="4803169" y="1833555"/>
+            <a:ext cx="1882766" cy="923330"/>
+          </a:xfrm>
+          <a:prstGeom prst="rect">
+            <a:avLst/>
+          </a:prstGeom>
+          <a:noFill/>
+        </p:spPr>
+        <p:txBody>
+          <a:bodyPr wrap="square" rtlCol="0">
+            <a:spAutoFit/>
+          </a:bodyPr>
+          <a:lstStyle/>
+          <a:p>
+            <a:r>
+              <a:rPr lang="en-US" dirty="0"/>
+              <a:t>Ways: To push the contents in vs code </a:t>
+            </a:r>
+            <a:endParaRPr lang="en-IN" dirty="0"/>
+          </a:p>
+        </p:txBody>
+      </p:sp>
+      <p:sp>
+        <p:nvSpPr>
+          <p:cNvPr id="10" name="Rectangle 9">
+            <a:extLst>
+              <a:ext uri="{FF2B5EF4-FFF2-40B4-BE49-F238E27FC236}">
+                <a16:creationId xmlns:a16="http://schemas.microsoft.com/office/drawing/2014/main" id="{893E2E99-BFBF-0C7D-29A1-9FFCACCFD9B2}"/>
+              </a:ext>
+            </a:extLst>
+          </p:cNvPr>
+          <p:cNvSpPr/>
+          <p:nvPr/>
+        </p:nvSpPr>
+        <p:spPr>
+          <a:xfrm>
+            <a:off x="2369574" y="490061"/>
+            <a:ext cx="363794" cy="375178"/>
+          </a:xfrm>
+          <a:prstGeom prst="rect">
+            <a:avLst/>
+          </a:prstGeom>
+          <a:noFill/>
+          <a:ln w="19050">
+            <a:solidFill>
+              <a:srgbClr val="FF0000"/>
+            </a:solidFill>
+          </a:ln>
+        </p:spPr>
+        <p:style>
+          <a:lnRef idx="2">
+            <a:schemeClr val="accent1">
+              <a:shade val="15000"/>
+            </a:schemeClr>
+          </a:lnRef>
+          <a:fillRef idx="1">
+            <a:schemeClr val="accent1"/>
+          </a:fillRef>
+          <a:effectRef idx="0">
+            <a:schemeClr val="accent1"/>
+          </a:effectRef>
+          <a:fontRef idx="minor">
+            <a:schemeClr val="lt1"/>
+          </a:fontRef>
+        </p:style>
+        <p:txBody>
+          <a:bodyPr rtlCol="0" anchor="ctr"/>
+          <a:lstStyle/>
+          <a:p>
+            <a:pPr algn="ctr"/>
+            <a:endParaRPr lang="en-IN"/>
+          </a:p>
+        </p:txBody>
+      </p:sp>
+      <p:sp>
+        <p:nvSpPr>
+          <p:cNvPr id="11" name="Rectangle 10">
+            <a:extLst>
+              <a:ext uri="{FF2B5EF4-FFF2-40B4-BE49-F238E27FC236}">
+                <a16:creationId xmlns:a16="http://schemas.microsoft.com/office/drawing/2014/main" id="{83CD67FA-E579-20F2-CCE6-B62E403BE204}"/>
+              </a:ext>
+            </a:extLst>
+          </p:cNvPr>
+          <p:cNvSpPr/>
+          <p:nvPr/>
+        </p:nvSpPr>
+        <p:spPr>
+          <a:xfrm>
+            <a:off x="9552038" y="1385572"/>
+            <a:ext cx="363794" cy="375178"/>
+          </a:xfrm>
+          <a:prstGeom prst="rect">
+            <a:avLst/>
+          </a:prstGeom>
+          <a:noFill/>
+          <a:ln w="19050">
+            <a:solidFill>
+              <a:srgbClr val="FF0000"/>
+            </a:solidFill>
+          </a:ln>
+        </p:spPr>
+        <p:style>
+          <a:lnRef idx="2">
+            <a:schemeClr val="accent1">
+              <a:shade val="15000"/>
+            </a:schemeClr>
+          </a:lnRef>
+          <a:fillRef idx="1">
+            <a:schemeClr val="accent1"/>
+          </a:fillRef>
+          <a:effectRef idx="0">
+            <a:schemeClr val="accent1"/>
+          </a:effectRef>
+          <a:fontRef idx="minor">
+            <a:schemeClr val="lt1"/>
+          </a:fontRef>
+        </p:style>
+        <p:txBody>
+          <a:bodyPr rtlCol="0" anchor="ctr"/>
+          <a:lstStyle/>
+          <a:p>
+            <a:pPr algn="ctr"/>
+            <a:endParaRPr lang="en-IN"/>
+          </a:p>
+        </p:txBody>
+      </p:sp>
+      <p:sp>
+        <p:nvSpPr>
+          <p:cNvPr id="13" name="TextBox 12">
+            <a:extLst>
+              <a:ext uri="{FF2B5EF4-FFF2-40B4-BE49-F238E27FC236}">
+                <a16:creationId xmlns:a16="http://schemas.microsoft.com/office/drawing/2014/main" id="{A275A9EE-B97F-16F3-FE86-3619A28EB491}"/>
+              </a:ext>
+            </a:extLst>
+          </p:cNvPr>
+          <p:cNvSpPr txBox="1"/>
+          <p:nvPr/>
+        </p:nvSpPr>
+        <p:spPr>
+          <a:xfrm>
+            <a:off x="6538452" y="4355690"/>
+            <a:ext cx="4227871" cy="1477328"/>
+          </a:xfrm>
+          <a:prstGeom prst="rect">
+            <a:avLst/>
+          </a:prstGeom>
+          <a:noFill/>
+        </p:spPr>
+        <p:txBody>
+          <a:bodyPr wrap="square" rtlCol="0">
+            <a:spAutoFit/>
+          </a:bodyPr>
+          <a:lstStyle/>
+          <a:p>
+            <a:r>
+              <a:rPr lang="en-US" dirty="0"/>
+              <a:t>After the staged changes ,commit with message and at last push </a:t>
+            </a:r>
+          </a:p>
+          <a:p>
+            <a:endParaRPr lang="en-US" dirty="0"/>
+          </a:p>
+          <a:p>
+            <a:r>
+              <a:rPr lang="en-US" dirty="0"/>
+              <a:t>Result is reflected in </a:t>
+            </a:r>
+            <a:r>
+              <a:rPr lang="en-US" dirty="0" err="1"/>
+              <a:t>github</a:t>
+            </a:r>
+            <a:br>
+              <a:rPr lang="en-US" dirty="0"/>
+            </a:br>
+            <a:r>
+              <a:rPr lang="en-US" dirty="0"/>
+              <a:t>you can able to see the commit message</a:t>
+            </a:r>
+            <a:endParaRPr lang="en-IN" dirty="0"/>
+          </a:p>
+        </p:txBody>
+      </p:sp>
+      <p:sp>
+        <p:nvSpPr>
+          <p:cNvPr id="15" name="Rectangle 14">
+            <a:extLst>
+              <a:ext uri="{FF2B5EF4-FFF2-40B4-BE49-F238E27FC236}">
+                <a16:creationId xmlns:a16="http://schemas.microsoft.com/office/drawing/2014/main" id="{032AF8F2-8BEE-2329-967A-8B730D6B5018}"/>
+              </a:ext>
+            </a:extLst>
+          </p:cNvPr>
+          <p:cNvSpPr/>
+          <p:nvPr/>
+        </p:nvSpPr>
+        <p:spPr>
+          <a:xfrm>
+            <a:off x="1120877" y="5732206"/>
+            <a:ext cx="3470788" cy="432001"/>
+          </a:xfrm>
+          <a:prstGeom prst="rect">
+            <a:avLst/>
+          </a:prstGeom>
+          <a:noFill/>
+          <a:ln>
+            <a:solidFill>
+              <a:srgbClr val="FF0000"/>
+            </a:solidFill>
+          </a:ln>
+        </p:spPr>
+        <p:style>
+          <a:lnRef idx="2">
+            <a:schemeClr val="accent1">
+              <a:shade val="15000"/>
+            </a:schemeClr>
+          </a:lnRef>
+          <a:fillRef idx="1">
+            <a:schemeClr val="accent1"/>
+          </a:fillRef>
+          <a:effectRef idx="0">
+            <a:schemeClr val="accent1"/>
+          </a:effectRef>
+          <a:fontRef idx="minor">
+            <a:schemeClr val="lt1"/>
+          </a:fontRef>
+        </p:style>
+        <p:txBody>
+          <a:bodyPr rtlCol="0" anchor="ctr"/>
+          <a:lstStyle/>
+          <a:p>
+            <a:pPr algn="ctr"/>
+            <a:endParaRPr lang="en-IN"/>
+          </a:p>
+        </p:txBody>
+      </p:sp>
+    </p:spTree>
+    <p:extLst>
+      <p:ext uri="{BB962C8B-B14F-4D97-AF65-F5344CB8AC3E}">
+        <p14:creationId xmlns:p14="http://schemas.microsoft.com/office/powerpoint/2010/main" val="1315096350"/>
+      </p:ext>
+    </p:extLst>
+  </p:cSld>
+  <p:clrMapOvr>
+    <a:masterClrMapping/>
+  </p:clrMapOvr>
+</p:sld>
+</file>
+
+<file path=ppt/slides/slide8.xml><?xml version="1.0" encoding="utf-8"?>
+<p:sld xmlns:a="http://schemas.openxmlformats.org/drawingml/2006/main" xmlns:r="http://schemas.openxmlformats.org/officeDocument/2006/relationships" xmlns:p="http://schemas.openxmlformats.org/presentationml/2006/main">
+  <p:cSld>
+    <p:spTree>
+      <p:nvGrpSpPr>
+        <p:cNvPr id="1" name=""/>
+        <p:cNvGrpSpPr/>
+        <p:nvPr/>
+      </p:nvGrpSpPr>
+      <p:grpSpPr>
+        <a:xfrm>
+          <a:off x="0" y="0"/>
+          <a:ext cx="0" cy="0"/>
+          <a:chOff x="0" y="0"/>
+          <a:chExt cx="0" cy="0"/>
+        </a:xfrm>
+      </p:grpSpPr>
+      <p:sp>
+        <p:nvSpPr>
           <p:cNvPr id="2" name="Title 1">
             <a:extLst>
               <a:ext uri="{FF2B5EF4-FFF2-40B4-BE49-F238E27FC236}">
@@ -4566,13 +6432,16 @@
           <a:bodyPr/>
           <a:lstStyle/>
           <a:p>
+            <a:pPr marL="0" indent="0">
+              <a:buNone/>
+            </a:pPr>
             <a:r>
               <a:rPr lang="en-US" dirty="0">
                 <a:solidFill>
                   <a:srgbClr val="0070C0"/>
                 </a:solidFill>
               </a:rPr>
-              <a:t>Git clone “</a:t>
+              <a:t>git clone “</a:t>
             </a:r>
             <a:r>
               <a:rPr lang="en-US" dirty="0" err="1">
@@ -4604,18 +6473,12 @@
               <a:buNone/>
             </a:pPr>
             <a:r>
-              <a:rPr lang="en-US" dirty="0"/>
-              <a:t>Use another branch-</a:t>
-            </a:r>
-          </a:p>
-          <a:p>
-            <a:r>
               <a:rPr lang="en-US" dirty="0">
                 <a:solidFill>
                   <a:srgbClr val="0070C0"/>
                 </a:solidFill>
               </a:rPr>
-              <a:t>Git clone “</a:t>
+              <a:t>git clone “</a:t>
             </a:r>
             <a:r>
               <a:rPr lang="en-US" dirty="0" err="1">
@@ -4657,6 +6520,171 @@
               </a:rPr>
               <a:t>”</a:t>
             </a:r>
+          </a:p>
+          <a:p>
+            <a:pPr marL="0" indent="0">
+              <a:buNone/>
+            </a:pPr>
+            <a:r>
+              <a:rPr lang="en-US" dirty="0">
+                <a:solidFill>
+                  <a:srgbClr val="0070C0"/>
+                </a:solidFill>
+              </a:rPr>
+              <a:t>git branch</a:t>
+            </a:r>
+          </a:p>
+          <a:p>
+            <a:pPr marL="0" indent="0">
+              <a:buNone/>
+            </a:pPr>
+            <a:r>
+              <a:rPr lang="en-US" dirty="0">
+                <a:solidFill>
+                  <a:srgbClr val="0070C0"/>
+                </a:solidFill>
+              </a:rPr>
+              <a:t>git checkout “</a:t>
+            </a:r>
+            <a:r>
+              <a:rPr lang="en-US" dirty="0">
+                <a:solidFill>
+                  <a:schemeClr val="accent6"/>
+                </a:solidFill>
+              </a:rPr>
+              <a:t>choose</a:t>
+            </a:r>
+            <a:r>
+              <a:rPr lang="en-US" dirty="0">
+                <a:solidFill>
+                  <a:srgbClr val="0070C0"/>
+                </a:solidFill>
+              </a:rPr>
+              <a:t> </a:t>
+            </a:r>
+            <a:r>
+              <a:rPr lang="en-US" dirty="0">
+                <a:solidFill>
+                  <a:schemeClr val="accent6"/>
+                </a:solidFill>
+              </a:rPr>
+              <a:t>the branch name</a:t>
+            </a:r>
+            <a:r>
+              <a:rPr lang="en-US" dirty="0">
+                <a:solidFill>
+                  <a:srgbClr val="0070C0"/>
+                </a:solidFill>
+              </a:rPr>
+              <a:t>" </a:t>
+            </a:r>
+          </a:p>
+          <a:p>
+            <a:pPr marL="0" indent="0">
+              <a:buNone/>
+            </a:pPr>
+            <a:r>
+              <a:rPr lang="en-US" dirty="0">
+                <a:solidFill>
+                  <a:srgbClr val="0070C0"/>
+                </a:solidFill>
+              </a:rPr>
+              <a:t>git add .</a:t>
+            </a:r>
+          </a:p>
+          <a:p>
+            <a:pPr marL="0" indent="0">
+              <a:buNone/>
+            </a:pPr>
+            <a:r>
+              <a:rPr lang="en-US" dirty="0">
+                <a:solidFill>
+                  <a:srgbClr val="0070C0"/>
+                </a:solidFill>
+              </a:rPr>
+              <a:t>git reset </a:t>
+            </a:r>
+            <a:r>
+              <a:rPr lang="en-US" dirty="0" err="1">
+                <a:solidFill>
+                  <a:schemeClr val="accent6"/>
+                </a:solidFill>
+              </a:rPr>
+              <a:t>staged_filename</a:t>
+            </a:r>
+            <a:endParaRPr lang="en-US" dirty="0">
+              <a:solidFill>
+                <a:schemeClr val="accent6"/>
+              </a:solidFill>
+            </a:endParaRPr>
+          </a:p>
+          <a:p>
+            <a:pPr marL="0" indent="0">
+              <a:buNone/>
+            </a:pPr>
+            <a:r>
+              <a:rPr lang="en-US" dirty="0">
+                <a:solidFill>
+                  <a:srgbClr val="0070C0"/>
+                </a:solidFill>
+              </a:rPr>
+              <a:t>git commit –m “</a:t>
+            </a:r>
+            <a:r>
+              <a:rPr lang="en-US" dirty="0">
+                <a:solidFill>
+                  <a:schemeClr val="accent6"/>
+                </a:solidFill>
+              </a:rPr>
+              <a:t>commit</a:t>
+            </a:r>
+            <a:r>
+              <a:rPr lang="en-US" dirty="0">
+                <a:solidFill>
+                  <a:srgbClr val="0070C0"/>
+                </a:solidFill>
+              </a:rPr>
+              <a:t> </a:t>
+            </a:r>
+            <a:r>
+              <a:rPr lang="en-US" dirty="0">
+                <a:solidFill>
+                  <a:schemeClr val="accent6"/>
+                </a:solidFill>
+              </a:rPr>
+              <a:t>message</a:t>
+            </a:r>
+            <a:r>
+              <a:rPr lang="en-US" dirty="0">
+                <a:solidFill>
+                  <a:srgbClr val="0070C0"/>
+                </a:solidFill>
+              </a:rPr>
+              <a:t>”</a:t>
+            </a:r>
+          </a:p>
+          <a:p>
+            <a:pPr marL="0" indent="0">
+              <a:buNone/>
+            </a:pPr>
+            <a:r>
+              <a:rPr lang="en-US" dirty="0">
+                <a:solidFill>
+                  <a:srgbClr val="0070C0"/>
+                </a:solidFill>
+              </a:rPr>
+              <a:t>git push</a:t>
+            </a:r>
+          </a:p>
+          <a:p>
+            <a:pPr marL="0" indent="0">
+              <a:buNone/>
+            </a:pPr>
+            <a:endParaRPr lang="en-US" dirty="0">
+              <a:solidFill>
+                <a:srgbClr val="0070C0"/>
+              </a:solidFill>
+            </a:endParaRPr>
           </a:p>
           <a:p>
             <a:endParaRPr lang="en-US" dirty="0">
@@ -4690,7 +6718,7 @@
 </p:sld>
 </file>
 
-<file path=ppt/slides/slide8.xml><?xml version="1.0" encoding="utf-8"?>
+<file path=ppt/slides/slide9.xml><?xml version="1.0" encoding="utf-8"?>
 <p:sld xmlns:a="http://schemas.openxmlformats.org/drawingml/2006/main" xmlns:r="http://schemas.openxmlformats.org/officeDocument/2006/relationships" xmlns:p="http://schemas.openxmlformats.org/presentationml/2006/main">
   <p:cSld>
     <p:spTree>
@@ -5078,4 +7106,299 @@
     </a:ext>
   </a:extLst>
 </a:theme>
+</file>
+
+<file path=ppt/theme/theme2.xml><?xml version="1.0" encoding="utf-8"?>
+<a:theme xmlns:a="http://schemas.openxmlformats.org/drawingml/2006/main" name="Office Theme">
+  <a:themeElements>
+    <a:clrScheme name="Office">
+      <a:dk1>
+        <a:sysClr val="windowText" lastClr="000000"/>
+      </a:dk1>
+      <a:lt1>
+        <a:sysClr val="window" lastClr="FFFFFF"/>
+      </a:lt1>
+      <a:dk2>
+        <a:srgbClr val="44546A"/>
+      </a:dk2>
+      <a:lt2>
+        <a:srgbClr val="E7E6E6"/>
+      </a:lt2>
+      <a:accent1>
+        <a:srgbClr val="4472C4"/>
+      </a:accent1>
+      <a:accent2>
+        <a:srgbClr val="ED7D31"/>
+      </a:accent2>
+      <a:accent3>
+        <a:srgbClr val="A5A5A5"/>
+      </a:accent3>
+      <a:accent4>
+        <a:srgbClr val="FFC000"/>
+      </a:accent4>
+      <a:accent5>
+        <a:srgbClr val="5B9BD5"/>
+      </a:accent5>
+      <a:accent6>
+        <a:srgbClr val="70AD47"/>
+      </a:accent6>
+      <a:hlink>
+        <a:srgbClr val="0563C1"/>
+      </a:hlink>
+      <a:folHlink>
+        <a:srgbClr val="954F72"/>
+      </a:folHlink>
+    </a:clrScheme>
+    <a:fontScheme name="Office">
+      <a:majorFont>
+        <a:latin typeface="Calibri Light" panose="020F0302020204030204"/>
+        <a:ea typeface=""/>
+        <a:cs typeface=""/>
+        <a:font script="Jpan" typeface="游ゴシック Light"/>
+        <a:font script="Hang" typeface="맑은 고딕"/>
+        <a:font script="Hans" typeface="等线 Light"/>
+        <a:font script="Hant" typeface="新細明體"/>
+        <a:font script="Arab" typeface="Times New Roman"/>
+        <a:font script="Hebr" typeface="Times New Roman"/>
+        <a:font script="Thai" typeface="Angsana New"/>
+        <a:font script="Ethi" typeface="Nyala"/>
+        <a:font script="Beng" typeface="Vrinda"/>
+        <a:font script="Gujr" typeface="Shruti"/>
+        <a:font script="Khmr" typeface="MoolBoran"/>
+        <a:font script="Knda" typeface="Tunga"/>
+        <a:font script="Guru" typeface="Raavi"/>
+        <a:font script="Cans" typeface="Euphemia"/>
+        <a:font script="Cher" typeface="Plantagenet Cherokee"/>
+        <a:font script="Yiii" typeface="Microsoft Yi Baiti"/>
+        <a:font script="Tibt" typeface="Microsoft Himalaya"/>
+        <a:font script="Thaa" typeface="MV Boli"/>
+        <a:font script="Deva" typeface="Mangal"/>
+        <a:font script="Telu" typeface="Gautami"/>
+        <a:font script="Taml" typeface="Latha"/>
+        <a:font script="Syrc" typeface="Estrangelo Edessa"/>
+        <a:font script="Orya" typeface="Kalinga"/>
+        <a:font script="Mlym" typeface="Kartika"/>
+        <a:font script="Laoo" typeface="DokChampa"/>
+        <a:font script="Sinh" typeface="Iskoola Pota"/>
+        <a:font script="Mong" typeface="Mongolian Baiti"/>
+        <a:font script="Viet" typeface="Times New Roman"/>
+        <a:font script="Uigh" typeface="Microsoft Uighur"/>
+        <a:font script="Geor" typeface="Sylfaen"/>
+        <a:font script="Armn" typeface="Arial"/>
+        <a:font script="Bugi" typeface="Leelawadee UI"/>
+        <a:font script="Bopo" typeface="Microsoft JhengHei"/>
+        <a:font script="Java" typeface="Javanese Text"/>
+        <a:font script="Lisu" typeface="Segoe UI"/>
+        <a:font script="Mymr" typeface="Myanmar Text"/>
+        <a:font script="Nkoo" typeface="Ebrima"/>
+        <a:font script="Olck" typeface="Nirmala UI"/>
+        <a:font script="Osma" typeface="Ebrima"/>
+        <a:font script="Phag" typeface="Phagspa"/>
+        <a:font script="Syrn" typeface="Estrangelo Edessa"/>
+        <a:font script="Syrj" typeface="Estrangelo Edessa"/>
+        <a:font script="Syre" typeface="Estrangelo Edessa"/>
+        <a:font script="Sora" typeface="Nirmala UI"/>
+        <a:font script="Tale" typeface="Microsoft Tai Le"/>
+        <a:font script="Talu" typeface="Microsoft New Tai Lue"/>
+        <a:font script="Tfng" typeface="Ebrima"/>
+      </a:majorFont>
+      <a:minorFont>
+        <a:latin typeface="Calibri" panose="020F0502020204030204"/>
+        <a:ea typeface=""/>
+        <a:cs typeface=""/>
+        <a:font script="Jpan" typeface="游ゴシック"/>
+        <a:font script="Hang" typeface="맑은 고딕"/>
+        <a:font script="Hans" typeface="等线"/>
+        <a:font script="Hant" typeface="新細明體"/>
+        <a:font script="Arab" typeface="Arial"/>
+        <a:font script="Hebr" typeface="Arial"/>
+        <a:font script="Thai" typeface="Cordia New"/>
+        <a:font script="Ethi" typeface="Nyala"/>
+        <a:font script="Beng" typeface="Vrinda"/>
+        <a:font script="Gujr" typeface="Shruti"/>
+        <a:font script="Khmr" typeface="DaunPenh"/>
+        <a:font script="Knda" typeface="Tunga"/>
+        <a:font script="Guru" typeface="Raavi"/>
+        <a:font script="Cans" typeface="Euphemia"/>
+        <a:font script="Cher" typeface="Plantagenet Cherokee"/>
+        <a:font script="Yiii" typeface="Microsoft Yi Baiti"/>
+        <a:font script="Tibt" typeface="Microsoft Himalaya"/>
+        <a:font script="Thaa" typeface="MV Boli"/>
+        <a:font script="Deva" typeface="Mangal"/>
+        <a:font script="Telu" typeface="Gautami"/>
+        <a:font script="Taml" typeface="Latha"/>
+        <a:font script="Syrc" typeface="Estrangelo Edessa"/>
+        <a:font script="Orya" typeface="Kalinga"/>
+        <a:font script="Mlym" typeface="Kartika"/>
+        <a:font script="Laoo" typeface="DokChampa"/>
+        <a:font script="Sinh" typeface="Iskoola Pota"/>
+        <a:font script="Mong" typeface="Mongolian Baiti"/>
+        <a:font script="Viet" typeface="Arial"/>
+        <a:font script="Uigh" typeface="Microsoft Uighur"/>
+        <a:font script="Geor" typeface="Sylfaen"/>
+        <a:font script="Armn" typeface="Arial"/>
+        <a:font script="Bugi" typeface="Leelawadee UI"/>
+        <a:font script="Bopo" typeface="Microsoft JhengHei"/>
+        <a:font script="Java" typeface="Javanese Text"/>
+        <a:font script="Lisu" typeface="Segoe UI"/>
+        <a:font script="Mymr" typeface="Myanmar Text"/>
+        <a:font script="Nkoo" typeface="Ebrima"/>
+        <a:font script="Olck" typeface="Nirmala UI"/>
+        <a:font script="Osma" typeface="Ebrima"/>
+        <a:font script="Phag" typeface="Phagspa"/>
+        <a:font script="Syrn" typeface="Estrangelo Edessa"/>
+        <a:font script="Syrj" typeface="Estrangelo Edessa"/>
+        <a:font script="Syre" typeface="Estrangelo Edessa"/>
+        <a:font script="Sora" typeface="Nirmala UI"/>
+        <a:font script="Tale" typeface="Microsoft Tai Le"/>
+        <a:font script="Talu" typeface="Microsoft New Tai Lue"/>
+        <a:font script="Tfng" typeface="Ebrima"/>
+      </a:minorFont>
+    </a:fontScheme>
+    <a:fmtScheme name="Office">
+      <a:fillStyleLst>
+        <a:solidFill>
+          <a:schemeClr val="phClr"/>
+        </a:solidFill>
+        <a:gradFill rotWithShape="1">
+          <a:gsLst>
+            <a:gs pos="0">
+              <a:schemeClr val="phClr">
+                <a:lumMod val="110000"/>
+                <a:satMod val="105000"/>
+                <a:tint val="67000"/>
+              </a:schemeClr>
+            </a:gs>
+            <a:gs pos="50000">
+              <a:schemeClr val="phClr">
+                <a:lumMod val="105000"/>
+                <a:satMod val="103000"/>
+                <a:tint val="73000"/>
+              </a:schemeClr>
+            </a:gs>
+            <a:gs pos="100000">
+              <a:schemeClr val="phClr">
+                <a:lumMod val="105000"/>
+                <a:satMod val="109000"/>
+                <a:tint val="81000"/>
+              </a:schemeClr>
+            </a:gs>
+          </a:gsLst>
+          <a:lin ang="5400000" scaled="0"/>
+        </a:gradFill>
+        <a:gradFill rotWithShape="1">
+          <a:gsLst>
+            <a:gs pos="0">
+              <a:schemeClr val="phClr">
+                <a:satMod val="103000"/>
+                <a:lumMod val="102000"/>
+                <a:tint val="94000"/>
+              </a:schemeClr>
+            </a:gs>
+            <a:gs pos="50000">
+              <a:schemeClr val="phClr">
+                <a:satMod val="110000"/>
+                <a:lumMod val="100000"/>
+                <a:shade val="100000"/>
+              </a:schemeClr>
+            </a:gs>
+            <a:gs pos="100000">
+              <a:schemeClr val="phClr">
+                <a:lumMod val="99000"/>
+                <a:satMod val="120000"/>
+                <a:shade val="78000"/>
+              </a:schemeClr>
+            </a:gs>
+          </a:gsLst>
+          <a:lin ang="5400000" scaled="0"/>
+        </a:gradFill>
+      </a:fillStyleLst>
+      <a:lnStyleLst>
+        <a:ln w="6350" cap="flat" cmpd="sng" algn="ctr">
+          <a:solidFill>
+            <a:schemeClr val="phClr"/>
+          </a:solidFill>
+          <a:prstDash val="solid"/>
+          <a:miter lim="800000"/>
+        </a:ln>
+        <a:ln w="12700" cap="flat" cmpd="sng" algn="ctr">
+          <a:solidFill>
+            <a:schemeClr val="phClr"/>
+          </a:solidFill>
+          <a:prstDash val="solid"/>
+          <a:miter lim="800000"/>
+        </a:ln>
+        <a:ln w="19050" cap="flat" cmpd="sng" algn="ctr">
+          <a:solidFill>
+            <a:schemeClr val="phClr"/>
+          </a:solidFill>
+          <a:prstDash val="solid"/>
+          <a:miter lim="800000"/>
+        </a:ln>
+      </a:lnStyleLst>
+      <a:effectStyleLst>
+        <a:effectStyle>
+          <a:effectLst/>
+        </a:effectStyle>
+        <a:effectStyle>
+          <a:effectLst/>
+        </a:effectStyle>
+        <a:effectStyle>
+          <a:effectLst>
+            <a:outerShdw blurRad="57150" dist="19050" dir="5400000" algn="ctr" rotWithShape="0">
+              <a:srgbClr val="000000">
+                <a:alpha val="63000"/>
+              </a:srgbClr>
+            </a:outerShdw>
+          </a:effectLst>
+        </a:effectStyle>
+      </a:effectStyleLst>
+      <a:bgFillStyleLst>
+        <a:solidFill>
+          <a:schemeClr val="phClr"/>
+        </a:solidFill>
+        <a:solidFill>
+          <a:schemeClr val="phClr">
+            <a:tint val="95000"/>
+            <a:satMod val="170000"/>
+          </a:schemeClr>
+        </a:solidFill>
+        <a:gradFill rotWithShape="1">
+          <a:gsLst>
+            <a:gs pos="0">
+              <a:schemeClr val="phClr">
+                <a:tint val="93000"/>
+                <a:satMod val="150000"/>
+                <a:shade val="98000"/>
+                <a:lumMod val="102000"/>
+              </a:schemeClr>
+            </a:gs>
+            <a:gs pos="50000">
+              <a:schemeClr val="phClr">
+                <a:tint val="98000"/>
+                <a:satMod val="130000"/>
+                <a:shade val="90000"/>
+                <a:lumMod val="103000"/>
+              </a:schemeClr>
+            </a:gs>
+            <a:gs pos="100000">
+              <a:schemeClr val="phClr">
+                <a:shade val="63000"/>
+                <a:satMod val="120000"/>
+              </a:schemeClr>
+            </a:gs>
+          </a:gsLst>
+          <a:lin ang="5400000" scaled="0"/>
+        </a:gradFill>
+      </a:bgFillStyleLst>
+    </a:fmtScheme>
+  </a:themeElements>
+  <a:objectDefaults/>
+  <a:extraClrSchemeLst/>
+  <a:extLst>
+    <a:ext uri="{05A4C25C-085E-4340-85A3-A5531E510DB2}">
+      <thm15:themeFamily xmlns:thm15="http://schemas.microsoft.com/office/thememl/2012/main" name="Office Theme" id="{62F939B6-93AF-4DB8-9C6B-D6C7DFDC589F}" vid="{4A3C46E8-61CC-4603-A589-7422A47A8E4A}"/>
+    </a:ext>
+  </a:extLst>
+</a:theme>
 </file>
</xml_diff>

<commit_message>
chore :some changes in ppt of git
</commit_message>
<xml_diff>
--- a/Home_done_works/Documents/pptformats/LearningOfGit.pptx
+++ b/Home_done_works/Documents/pptformats/LearningOfGit.pptx
@@ -5,7 +5,7 @@
     <p:sldMasterId id="2147483648" r:id="rId1"/>
   </p:sldMasterIdLst>
   <p:notesMasterIdLst>
-    <p:notesMasterId r:id="rId12"/>
+    <p:notesMasterId r:id="rId16"/>
   </p:notesMasterIdLst>
   <p:sldIdLst>
     <p:sldId id="256" r:id="rId2"/>
@@ -15,9 +15,13 @@
     <p:sldId id="259" r:id="rId6"/>
     <p:sldId id="260" r:id="rId7"/>
     <p:sldId id="264" r:id="rId8"/>
-    <p:sldId id="261" r:id="rId9"/>
-    <p:sldId id="265" r:id="rId10"/>
-    <p:sldId id="262" r:id="rId11"/>
+    <p:sldId id="266" r:id="rId9"/>
+    <p:sldId id="267" r:id="rId10"/>
+    <p:sldId id="269" r:id="rId11"/>
+    <p:sldId id="268" r:id="rId12"/>
+    <p:sldId id="261" r:id="rId13"/>
+    <p:sldId id="265" r:id="rId14"/>
+    <p:sldId id="262" r:id="rId15"/>
   </p:sldIdLst>
   <p:sldSz cx="12192000" cy="6858000"/>
   <p:notesSz cx="6858000" cy="9144000"/>
@@ -3782,6 +3786,996 @@
       </p:grpSpPr>
       <p:sp>
         <p:nvSpPr>
+          <p:cNvPr id="2" name="Title 1">
+            <a:extLst>
+              <a:ext uri="{FF2B5EF4-FFF2-40B4-BE49-F238E27FC236}">
+                <a16:creationId xmlns:a16="http://schemas.microsoft.com/office/drawing/2014/main" id="{0D6A4BB6-99F7-9822-DA43-80D1FCC60886}"/>
+              </a:ext>
+            </a:extLst>
+          </p:cNvPr>
+          <p:cNvSpPr>
+            <a:spLocks noGrp="1"/>
+          </p:cNvSpPr>
+          <p:nvPr>
+            <p:ph type="title"/>
+          </p:nvPr>
+        </p:nvSpPr>
+        <p:spPr/>
+        <p:txBody>
+          <a:bodyPr/>
+          <a:lstStyle/>
+          <a:p>
+            <a:r>
+              <a:rPr lang="en-US" dirty="0"/>
+              <a:t>Merge conflict</a:t>
+            </a:r>
+            <a:endParaRPr lang="en-IN" dirty="0"/>
+          </a:p>
+        </p:txBody>
+      </p:sp>
+      <p:sp>
+        <p:nvSpPr>
+          <p:cNvPr id="3" name="Content Placeholder 2">
+            <a:extLst>
+              <a:ext uri="{FF2B5EF4-FFF2-40B4-BE49-F238E27FC236}">
+                <a16:creationId xmlns:a16="http://schemas.microsoft.com/office/drawing/2014/main" id="{61EEED36-679B-0BFE-9B03-DB0A11780CC7}"/>
+              </a:ext>
+            </a:extLst>
+          </p:cNvPr>
+          <p:cNvSpPr>
+            <a:spLocks noGrp="1"/>
+          </p:cNvSpPr>
+          <p:nvPr>
+            <p:ph idx="1"/>
+          </p:nvPr>
+        </p:nvSpPr>
+        <p:spPr/>
+        <p:txBody>
+          <a:bodyPr/>
+          <a:lstStyle/>
+          <a:p>
+            <a:pPr marL="0" indent="0">
+              <a:buNone/>
+            </a:pPr>
+            <a:r>
+              <a:rPr lang="en-US" dirty="0"/>
+              <a:t>Line 10 -My line</a:t>
+            </a:r>
+          </a:p>
+          <a:p>
+            <a:pPr marL="0" indent="0">
+              <a:buNone/>
+            </a:pPr>
+            <a:r>
+              <a:rPr lang="en-US" dirty="0"/>
+              <a:t>Team mate code </a:t>
+            </a:r>
+          </a:p>
+          <a:p>
+            <a:pPr marL="0" indent="0">
+              <a:buNone/>
+            </a:pPr>
+            <a:r>
+              <a:rPr lang="en-US" dirty="0"/>
+              <a:t>Line 10=teammates line</a:t>
+            </a:r>
+          </a:p>
+          <a:p>
+            <a:pPr marL="0" indent="0">
+              <a:buNone/>
+            </a:pPr>
+            <a:r>
+              <a:rPr lang="en-US" dirty="0"/>
+              <a:t>First we have taken the pull from main to be the latest code to be dropped in </a:t>
+            </a:r>
+            <a:r>
+              <a:rPr lang="en-US"/>
+              <a:t>main branch</a:t>
+            </a:r>
+            <a:endParaRPr lang="en-IN" dirty="0"/>
+          </a:p>
+        </p:txBody>
+      </p:sp>
+    </p:spTree>
+    <p:extLst>
+      <p:ext uri="{BB962C8B-B14F-4D97-AF65-F5344CB8AC3E}">
+        <p14:creationId xmlns:p14="http://schemas.microsoft.com/office/powerpoint/2010/main" val="172721249"/>
+      </p:ext>
+    </p:extLst>
+  </p:cSld>
+  <p:clrMapOvr>
+    <a:masterClrMapping/>
+  </p:clrMapOvr>
+</p:sld>
+</file>
+
+<file path=ppt/slides/slide11.xml><?xml version="1.0" encoding="utf-8"?>
+<p:sld xmlns:a="http://schemas.openxmlformats.org/drawingml/2006/main" xmlns:r="http://schemas.openxmlformats.org/officeDocument/2006/relationships" xmlns:p="http://schemas.openxmlformats.org/presentationml/2006/main">
+  <p:cSld>
+    <p:spTree>
+      <p:nvGrpSpPr>
+        <p:cNvPr id="1" name=""/>
+        <p:cNvGrpSpPr/>
+        <p:nvPr/>
+      </p:nvGrpSpPr>
+      <p:grpSpPr>
+        <a:xfrm>
+          <a:off x="0" y="0"/>
+          <a:ext cx="0" cy="0"/>
+          <a:chOff x="0" y="0"/>
+          <a:chExt cx="0" cy="0"/>
+        </a:xfrm>
+      </p:grpSpPr>
+      <p:sp>
+        <p:nvSpPr>
+          <p:cNvPr id="3" name="Content Placeholder 2">
+            <a:extLst>
+              <a:ext uri="{FF2B5EF4-FFF2-40B4-BE49-F238E27FC236}">
+                <a16:creationId xmlns:a16="http://schemas.microsoft.com/office/drawing/2014/main" id="{B486E513-452C-23DD-4C58-867338D42FEA}"/>
+              </a:ext>
+            </a:extLst>
+          </p:cNvPr>
+          <p:cNvSpPr>
+            <a:spLocks noGrp="1"/>
+          </p:cNvSpPr>
+          <p:nvPr>
+            <p:ph idx="1"/>
+          </p:nvPr>
+        </p:nvSpPr>
+        <p:spPr>
+          <a:xfrm>
+            <a:off x="403123" y="255639"/>
+            <a:ext cx="10950677" cy="5921324"/>
+          </a:xfrm>
+        </p:spPr>
+        <p:txBody>
+          <a:bodyPr>
+            <a:normAutofit fontScale="47500" lnSpcReduction="20000"/>
+          </a:bodyPr>
+          <a:lstStyle/>
+          <a:p>
+            <a:pPr marL="0" indent="0">
+              <a:buNone/>
+            </a:pPr>
+            <a:r>
+              <a:rPr lang="en-US" dirty="0"/>
+              <a:t>Git stash </a:t>
+            </a:r>
+          </a:p>
+          <a:p>
+            <a:pPr marL="0" indent="0">
+              <a:buNone/>
+            </a:pPr>
+            <a:r>
+              <a:rPr lang="en-US" dirty="0"/>
+              <a:t>Our side in 10 line I added </a:t>
+            </a:r>
+          </a:p>
+          <a:p>
+            <a:pPr marL="0" indent="0">
+              <a:buNone/>
+            </a:pPr>
+            <a:r>
+              <a:rPr lang="en-US" dirty="0"/>
+              <a:t>The line is not necessary</a:t>
+            </a:r>
+          </a:p>
+          <a:p>
+            <a:pPr marL="0" indent="0">
+              <a:buNone/>
+            </a:pPr>
+            <a:r>
+              <a:rPr lang="en-US" dirty="0"/>
+              <a:t>Other side the same 10 </a:t>
+            </a:r>
+            <a:r>
+              <a:rPr lang="en-US" dirty="0" err="1"/>
+              <a:t>th</a:t>
+            </a:r>
+            <a:r>
+              <a:rPr lang="en-US" dirty="0"/>
+              <a:t> line </a:t>
+            </a:r>
+          </a:p>
+          <a:p>
+            <a:pPr marL="0" indent="0">
+              <a:buNone/>
+            </a:pPr>
+            <a:r>
+              <a:rPr lang="en-US" dirty="0"/>
+              <a:t>This line is necessary to adapt teammates </a:t>
+            </a:r>
+          </a:p>
+          <a:p>
+            <a:pPr marL="0" indent="0">
+              <a:buNone/>
+            </a:pPr>
+            <a:r>
+              <a:rPr lang="en-US" dirty="0"/>
+              <a:t>Our side :</a:t>
+            </a:r>
+          </a:p>
+          <a:p>
+            <a:pPr marL="0" indent="0">
+              <a:buNone/>
+            </a:pPr>
+            <a:r>
+              <a:rPr lang="en-US" dirty="0"/>
+              <a:t>Git handling (this all done in single branch)</a:t>
+            </a:r>
+          </a:p>
+          <a:p>
+            <a:pPr marL="0" indent="0">
+              <a:buNone/>
+            </a:pPr>
+            <a:r>
+              <a:rPr lang="en-US" dirty="0" err="1"/>
+              <a:t>Firstwe</a:t>
+            </a:r>
+            <a:r>
+              <a:rPr lang="en-US" dirty="0"/>
+              <a:t> need to pull from others(because to get the changes)</a:t>
+            </a:r>
+          </a:p>
+          <a:p>
+            <a:pPr marL="0" indent="0">
+              <a:buNone/>
+            </a:pPr>
+            <a:r>
+              <a:rPr lang="en-US" dirty="0" err="1"/>
+              <a:t>Note:we</a:t>
+            </a:r>
+            <a:r>
+              <a:rPr lang="en-US" dirty="0"/>
+              <a:t> don’t </a:t>
+            </a:r>
+            <a:r>
+              <a:rPr lang="en-US" dirty="0" err="1"/>
+              <a:t>add,commit</a:t>
+            </a:r>
+            <a:r>
+              <a:rPr lang="en-US" dirty="0"/>
+              <a:t> in our code first we taken the pull mistakenly </a:t>
+            </a:r>
+          </a:p>
+          <a:p>
+            <a:pPr marL="0" indent="0">
+              <a:buNone/>
+            </a:pPr>
+            <a:r>
+              <a:rPr lang="en-US" dirty="0"/>
+              <a:t>Here the error throws </a:t>
+            </a:r>
+            <a:r>
+              <a:rPr lang="en-US" dirty="0">
+                <a:solidFill>
+                  <a:srgbClr val="FF0000"/>
+                </a:solidFill>
+              </a:rPr>
+              <a:t>abort</a:t>
+            </a:r>
+          </a:p>
+          <a:p>
+            <a:pPr marL="0" indent="0">
+              <a:buNone/>
+            </a:pPr>
+            <a:r>
+              <a:rPr lang="en-US" dirty="0"/>
+              <a:t>Please commit your changes or </a:t>
+            </a:r>
+            <a:r>
+              <a:rPr lang="en-US" dirty="0" err="1"/>
+              <a:t>unstash</a:t>
+            </a:r>
+            <a:r>
+              <a:rPr lang="en-US" dirty="0"/>
+              <a:t> them if not necessary (we can retrieve later)</a:t>
+            </a:r>
+          </a:p>
+          <a:p>
+            <a:pPr marL="0" indent="0">
+              <a:buNone/>
+            </a:pPr>
+            <a:r>
+              <a:rPr lang="en-US" dirty="0"/>
+              <a:t>So we use stash </a:t>
+            </a:r>
+            <a:r>
+              <a:rPr lang="en-US" dirty="0" err="1"/>
+              <a:t>cmd</a:t>
+            </a:r>
+            <a:endParaRPr lang="en-US" dirty="0"/>
+          </a:p>
+          <a:p>
+            <a:pPr marL="0" indent="0">
+              <a:buNone/>
+            </a:pPr>
+            <a:r>
+              <a:rPr lang="en-US" dirty="0">
+                <a:solidFill>
+                  <a:srgbClr val="FF0000"/>
+                </a:solidFill>
+              </a:rPr>
+              <a:t>Git stash– if not necessary I have given this </a:t>
+            </a:r>
+          </a:p>
+          <a:p>
+            <a:pPr marL="0" indent="0">
+              <a:buNone/>
+            </a:pPr>
+            <a:r>
+              <a:rPr lang="en-US" dirty="0">
+                <a:solidFill>
+                  <a:srgbClr val="FF0000"/>
+                </a:solidFill>
+              </a:rPr>
+              <a:t>Git pull means from other side </a:t>
+            </a:r>
+          </a:p>
+          <a:p>
+            <a:pPr marL="0" indent="0">
+              <a:buNone/>
+            </a:pPr>
+            <a:r>
+              <a:rPr lang="en-US" dirty="0"/>
+              <a:t>This line is necessary to adapt teammates </a:t>
+            </a:r>
+            <a:r>
+              <a:rPr lang="en-US" sz="2900" dirty="0">
+                <a:solidFill>
+                  <a:srgbClr val="FF0000"/>
+                </a:solidFill>
+              </a:rPr>
+              <a:t>in our code merges.</a:t>
+            </a:r>
+          </a:p>
+          <a:p>
+            <a:pPr marL="0" indent="0">
+              <a:buNone/>
+            </a:pPr>
+            <a:r>
+              <a:rPr lang="en-US" sz="2900" dirty="0">
+                <a:solidFill>
+                  <a:srgbClr val="FF0000"/>
+                </a:solidFill>
+              </a:rPr>
+              <a:t>If needed git add commit and push others code</a:t>
+            </a:r>
+          </a:p>
+          <a:p>
+            <a:pPr marL="0" indent="0">
+              <a:buNone/>
+            </a:pPr>
+            <a:r>
+              <a:rPr lang="en-US" sz="2900" dirty="0">
+                <a:solidFill>
+                  <a:srgbClr val="FF0000"/>
+                </a:solidFill>
+              </a:rPr>
+              <a:t>If not needed means git stash pop </a:t>
+            </a:r>
+            <a:r>
+              <a:rPr lang="en-US" sz="2900" dirty="0" err="1">
+                <a:solidFill>
+                  <a:srgbClr val="FF0000"/>
+                </a:solidFill>
+              </a:rPr>
+              <a:t>cmd</a:t>
+            </a:r>
+            <a:r>
+              <a:rPr lang="en-US" sz="2900" dirty="0">
+                <a:solidFill>
+                  <a:srgbClr val="FF0000"/>
+                </a:solidFill>
+              </a:rPr>
+              <a:t> to retrieve the our changes before add and commit</a:t>
+            </a:r>
+          </a:p>
+          <a:p>
+            <a:pPr marL="0" indent="0">
+              <a:buNone/>
+            </a:pPr>
+            <a:endParaRPr lang="en-US" sz="2900" dirty="0">
+              <a:solidFill>
+                <a:srgbClr val="FF0000"/>
+              </a:solidFill>
+            </a:endParaRPr>
+          </a:p>
+          <a:p>
+            <a:pPr marL="0" indent="0">
+              <a:buNone/>
+            </a:pPr>
+            <a:endParaRPr lang="en-US" sz="2900" dirty="0">
+              <a:solidFill>
+                <a:srgbClr val="FF0000"/>
+              </a:solidFill>
+            </a:endParaRPr>
+          </a:p>
+          <a:p>
+            <a:pPr marL="0" indent="0">
+              <a:buNone/>
+            </a:pPr>
+            <a:endParaRPr lang="en-US" dirty="0">
+              <a:solidFill>
+                <a:srgbClr val="FF0000"/>
+              </a:solidFill>
+            </a:endParaRPr>
+          </a:p>
+          <a:p>
+            <a:pPr marL="0" indent="0">
+              <a:buNone/>
+            </a:pPr>
+            <a:endParaRPr lang="en-US" dirty="0">
+              <a:solidFill>
+                <a:srgbClr val="FF0000"/>
+              </a:solidFill>
+            </a:endParaRPr>
+          </a:p>
+          <a:p>
+            <a:pPr marL="0" indent="0">
+              <a:buNone/>
+            </a:pPr>
+            <a:r>
+              <a:rPr lang="en-US" dirty="0"/>
+              <a:t> </a:t>
+            </a:r>
+            <a:endParaRPr lang="en-IN" dirty="0"/>
+          </a:p>
+        </p:txBody>
+      </p:sp>
+    </p:spTree>
+    <p:extLst>
+      <p:ext uri="{BB962C8B-B14F-4D97-AF65-F5344CB8AC3E}">
+        <p14:creationId xmlns:p14="http://schemas.microsoft.com/office/powerpoint/2010/main" val="201881865"/>
+      </p:ext>
+    </p:extLst>
+  </p:cSld>
+  <p:clrMapOvr>
+    <a:masterClrMapping/>
+  </p:clrMapOvr>
+</p:sld>
+</file>
+
+<file path=ppt/slides/slide12.xml><?xml version="1.0" encoding="utf-8"?>
+<p:sld xmlns:a="http://schemas.openxmlformats.org/drawingml/2006/main" xmlns:r="http://schemas.openxmlformats.org/officeDocument/2006/relationships" xmlns:p="http://schemas.openxmlformats.org/presentationml/2006/main">
+  <p:cSld>
+    <p:spTree>
+      <p:nvGrpSpPr>
+        <p:cNvPr id="1" name=""/>
+        <p:cNvGrpSpPr/>
+        <p:nvPr/>
+      </p:nvGrpSpPr>
+      <p:grpSpPr>
+        <a:xfrm>
+          <a:off x="0" y="0"/>
+          <a:ext cx="0" cy="0"/>
+          <a:chOff x="0" y="0"/>
+          <a:chExt cx="0" cy="0"/>
+        </a:xfrm>
+      </p:grpSpPr>
+      <p:sp>
+        <p:nvSpPr>
+          <p:cNvPr id="2" name="Title 1">
+            <a:extLst>
+              <a:ext uri="{FF2B5EF4-FFF2-40B4-BE49-F238E27FC236}">
+                <a16:creationId xmlns:a16="http://schemas.microsoft.com/office/drawing/2014/main" id="{2023C268-0263-861B-E91A-10861DDA3F2A}"/>
+              </a:ext>
+            </a:extLst>
+          </p:cNvPr>
+          <p:cNvSpPr>
+            <a:spLocks noGrp="1"/>
+          </p:cNvSpPr>
+          <p:nvPr>
+            <p:ph type="title"/>
+          </p:nvPr>
+        </p:nvSpPr>
+        <p:spPr/>
+        <p:txBody>
+          <a:bodyPr/>
+          <a:lstStyle/>
+          <a:p>
+            <a:r>
+              <a:rPr lang="en-US" dirty="0"/>
+              <a:t>Commands to learned😁</a:t>
+            </a:r>
+            <a:endParaRPr lang="en-IN" dirty="0"/>
+          </a:p>
+        </p:txBody>
+      </p:sp>
+      <p:sp>
+        <p:nvSpPr>
+          <p:cNvPr id="3" name="Content Placeholder 2">
+            <a:extLst>
+              <a:ext uri="{FF2B5EF4-FFF2-40B4-BE49-F238E27FC236}">
+                <a16:creationId xmlns:a16="http://schemas.microsoft.com/office/drawing/2014/main" id="{164FD01D-C4BC-B66B-A186-946FDDFF6F92}"/>
+              </a:ext>
+            </a:extLst>
+          </p:cNvPr>
+          <p:cNvSpPr>
+            <a:spLocks noGrp="1"/>
+          </p:cNvSpPr>
+          <p:nvPr>
+            <p:ph idx="1"/>
+          </p:nvPr>
+        </p:nvSpPr>
+        <p:spPr>
+          <a:xfrm>
+            <a:off x="838200" y="1533832"/>
+            <a:ext cx="10515600" cy="4643131"/>
+          </a:xfrm>
+        </p:spPr>
+        <p:txBody>
+          <a:bodyPr>
+            <a:normAutofit fontScale="85000" lnSpcReduction="20000"/>
+          </a:bodyPr>
+          <a:lstStyle/>
+          <a:p>
+            <a:pPr marL="0" indent="0">
+              <a:buNone/>
+            </a:pPr>
+            <a:r>
+              <a:rPr lang="en-US" sz="3200" dirty="0">
+                <a:solidFill>
+                  <a:srgbClr val="0070C0"/>
+                </a:solidFill>
+              </a:rPr>
+              <a:t>git clone “</a:t>
+            </a:r>
+            <a:r>
+              <a:rPr lang="en-US" sz="3200" dirty="0" err="1">
+                <a:solidFill>
+                  <a:schemeClr val="accent6"/>
+                </a:solidFill>
+              </a:rPr>
+              <a:t>url</a:t>
+            </a:r>
+            <a:r>
+              <a:rPr lang="en-US" sz="3200" dirty="0">
+                <a:solidFill>
+                  <a:schemeClr val="accent6"/>
+                </a:solidFill>
+              </a:rPr>
+              <a:t> of main branch</a:t>
+            </a:r>
+            <a:r>
+              <a:rPr lang="en-US" sz="3200" dirty="0">
+                <a:solidFill>
+                  <a:srgbClr val="0070C0"/>
+                </a:solidFill>
+              </a:rPr>
+              <a:t>”</a:t>
+            </a:r>
+          </a:p>
+          <a:p>
+            <a:pPr marL="0" indent="0">
+              <a:buNone/>
+            </a:pPr>
+            <a:r>
+              <a:rPr lang="en-US" sz="3200" dirty="0">
+                <a:solidFill>
+                  <a:srgbClr val="0070C0"/>
+                </a:solidFill>
+              </a:rPr>
+              <a:t>git clone “</a:t>
+            </a:r>
+            <a:r>
+              <a:rPr lang="en-US" sz="3200" dirty="0" err="1">
+                <a:solidFill>
+                  <a:schemeClr val="accent6"/>
+                </a:solidFill>
+              </a:rPr>
+              <a:t>url</a:t>
+            </a:r>
+            <a:r>
+              <a:rPr lang="en-US" sz="3200" dirty="0">
+                <a:solidFill>
+                  <a:schemeClr val="accent6"/>
+                </a:solidFill>
+              </a:rPr>
+              <a:t> of main branch</a:t>
+            </a:r>
+            <a:r>
+              <a:rPr lang="en-US" sz="3200" dirty="0">
+                <a:solidFill>
+                  <a:srgbClr val="0070C0"/>
+                </a:solidFill>
+              </a:rPr>
+              <a:t>”--branch=“</a:t>
+            </a:r>
+            <a:r>
+              <a:rPr lang="en-US" sz="3200" dirty="0" err="1">
+                <a:solidFill>
+                  <a:schemeClr val="accent6"/>
+                </a:solidFill>
+              </a:rPr>
+              <a:t>branch_name</a:t>
+            </a:r>
+            <a:r>
+              <a:rPr lang="en-US" sz="3200" dirty="0">
+                <a:solidFill>
+                  <a:srgbClr val="0070C0"/>
+                </a:solidFill>
+              </a:rPr>
+              <a:t>”</a:t>
+            </a:r>
+          </a:p>
+          <a:p>
+            <a:pPr marL="0" indent="0">
+              <a:buNone/>
+            </a:pPr>
+            <a:r>
+              <a:rPr lang="en-US" sz="3200" dirty="0">
+                <a:solidFill>
+                  <a:srgbClr val="0070C0"/>
+                </a:solidFill>
+              </a:rPr>
+              <a:t>git branch</a:t>
+            </a:r>
+          </a:p>
+          <a:p>
+            <a:pPr marL="0" indent="0">
+              <a:buNone/>
+            </a:pPr>
+            <a:r>
+              <a:rPr lang="en-US" sz="3200" dirty="0">
+                <a:solidFill>
+                  <a:srgbClr val="0070C0"/>
+                </a:solidFill>
+              </a:rPr>
+              <a:t>Git checkout–b “</a:t>
+            </a:r>
+            <a:r>
+              <a:rPr lang="en-US" sz="3200" dirty="0">
+                <a:solidFill>
+                  <a:schemeClr val="accent6"/>
+                </a:solidFill>
+              </a:rPr>
+              <a:t>new branch name for creation</a:t>
+            </a:r>
+            <a:r>
+              <a:rPr lang="en-US" sz="3200" dirty="0">
+                <a:solidFill>
+                  <a:srgbClr val="0070C0"/>
+                </a:solidFill>
+              </a:rPr>
+              <a:t>”</a:t>
+            </a:r>
+          </a:p>
+          <a:p>
+            <a:pPr marL="0" indent="0">
+              <a:buNone/>
+            </a:pPr>
+            <a:r>
+              <a:rPr lang="en-US" sz="3200" dirty="0">
+                <a:solidFill>
+                  <a:srgbClr val="0070C0"/>
+                </a:solidFill>
+              </a:rPr>
+              <a:t>git checkout “</a:t>
+            </a:r>
+            <a:r>
+              <a:rPr lang="en-US" sz="3200" dirty="0">
+                <a:solidFill>
+                  <a:schemeClr val="accent6"/>
+                </a:solidFill>
+              </a:rPr>
+              <a:t>choose</a:t>
+            </a:r>
+            <a:r>
+              <a:rPr lang="en-US" sz="3200" dirty="0">
+                <a:solidFill>
+                  <a:srgbClr val="0070C0"/>
+                </a:solidFill>
+              </a:rPr>
+              <a:t> </a:t>
+            </a:r>
+            <a:r>
+              <a:rPr lang="en-US" sz="3200" dirty="0">
+                <a:solidFill>
+                  <a:schemeClr val="accent6"/>
+                </a:solidFill>
+              </a:rPr>
+              <a:t>the branch name</a:t>
+            </a:r>
+            <a:r>
+              <a:rPr lang="en-US" sz="3200" dirty="0">
+                <a:solidFill>
+                  <a:srgbClr val="0070C0"/>
+                </a:solidFill>
+              </a:rPr>
+              <a:t>" </a:t>
+            </a:r>
+          </a:p>
+          <a:p>
+            <a:pPr marL="0" indent="0">
+              <a:buNone/>
+            </a:pPr>
+            <a:r>
+              <a:rPr lang="en-US" sz="3200" dirty="0">
+                <a:solidFill>
+                  <a:srgbClr val="0070C0"/>
+                </a:solidFill>
+              </a:rPr>
+              <a:t>git add .</a:t>
+            </a:r>
+          </a:p>
+          <a:p>
+            <a:pPr marL="0" indent="0">
+              <a:buNone/>
+            </a:pPr>
+            <a:r>
+              <a:rPr lang="en-US" sz="3200" dirty="0">
+                <a:solidFill>
+                  <a:srgbClr val="0070C0"/>
+                </a:solidFill>
+              </a:rPr>
+              <a:t>git reset </a:t>
+            </a:r>
+            <a:r>
+              <a:rPr lang="en-US" sz="3200" dirty="0" err="1">
+                <a:solidFill>
+                  <a:schemeClr val="accent6"/>
+                </a:solidFill>
+              </a:rPr>
+              <a:t>staged_filename</a:t>
+            </a:r>
+            <a:endParaRPr lang="en-US" sz="3200" dirty="0">
+              <a:solidFill>
+                <a:schemeClr val="accent6"/>
+              </a:solidFill>
+            </a:endParaRPr>
+          </a:p>
+          <a:p>
+            <a:pPr marL="0" indent="0">
+              <a:buNone/>
+            </a:pPr>
+            <a:r>
+              <a:rPr lang="en-US" sz="3200" dirty="0">
+                <a:solidFill>
+                  <a:srgbClr val="0070C0"/>
+                </a:solidFill>
+              </a:rPr>
+              <a:t>git commit –m “</a:t>
+            </a:r>
+            <a:r>
+              <a:rPr lang="en-US" sz="3200" dirty="0">
+                <a:solidFill>
+                  <a:schemeClr val="accent6"/>
+                </a:solidFill>
+              </a:rPr>
+              <a:t>commit</a:t>
+            </a:r>
+            <a:r>
+              <a:rPr lang="en-US" sz="3200" dirty="0">
+                <a:solidFill>
+                  <a:srgbClr val="0070C0"/>
+                </a:solidFill>
+              </a:rPr>
+              <a:t> </a:t>
+            </a:r>
+            <a:r>
+              <a:rPr lang="en-US" sz="3200" dirty="0">
+                <a:solidFill>
+                  <a:schemeClr val="accent6"/>
+                </a:solidFill>
+              </a:rPr>
+              <a:t>message</a:t>
+            </a:r>
+            <a:r>
+              <a:rPr lang="en-US" sz="3200" dirty="0">
+                <a:solidFill>
+                  <a:srgbClr val="0070C0"/>
+                </a:solidFill>
+              </a:rPr>
+              <a:t>”</a:t>
+            </a:r>
+          </a:p>
+          <a:p>
+            <a:pPr marL="0" indent="0">
+              <a:buNone/>
+            </a:pPr>
+            <a:r>
+              <a:rPr lang="en-US" sz="3200" dirty="0">
+                <a:solidFill>
+                  <a:srgbClr val="0070C0"/>
+                </a:solidFill>
+              </a:rPr>
+              <a:t>git push</a:t>
+            </a:r>
+          </a:p>
+          <a:p>
+            <a:pPr marL="0" indent="0">
+              <a:buNone/>
+            </a:pPr>
+            <a:r>
+              <a:rPr lang="en-US" sz="3200" dirty="0">
+                <a:solidFill>
+                  <a:srgbClr val="0070C0"/>
+                </a:solidFill>
+              </a:rPr>
+              <a:t>git push origin </a:t>
+            </a:r>
+            <a:r>
+              <a:rPr lang="en-US" sz="3200" dirty="0" err="1">
+                <a:solidFill>
+                  <a:schemeClr val="accent6"/>
+                </a:solidFill>
+              </a:rPr>
+              <a:t>branchname</a:t>
+            </a:r>
+            <a:r>
+              <a:rPr lang="en-US" sz="3200" dirty="0">
+                <a:solidFill>
+                  <a:srgbClr val="0070C0"/>
+                </a:solidFill>
+              </a:rPr>
+              <a:t> </a:t>
+            </a:r>
+          </a:p>
+          <a:p>
+            <a:pPr marL="0" indent="0">
+              <a:buNone/>
+            </a:pPr>
+            <a:r>
+              <a:rPr lang="en-US" sz="3200" dirty="0">
+                <a:solidFill>
+                  <a:srgbClr val="0070C0"/>
+                </a:solidFill>
+              </a:rPr>
+              <a:t>Git pull </a:t>
+            </a:r>
+          </a:p>
+          <a:p>
+            <a:pPr marL="0" indent="0">
+              <a:buNone/>
+            </a:pPr>
+            <a:endParaRPr lang="en-US" sz="3200" dirty="0">
+              <a:solidFill>
+                <a:srgbClr val="0070C0"/>
+              </a:solidFill>
+            </a:endParaRPr>
+          </a:p>
+          <a:p>
+            <a:pPr marL="0" indent="0">
+              <a:buNone/>
+            </a:pPr>
+            <a:endParaRPr lang="en-US" dirty="0">
+              <a:solidFill>
+                <a:srgbClr val="0070C0"/>
+              </a:solidFill>
+            </a:endParaRPr>
+          </a:p>
+          <a:p>
+            <a:endParaRPr lang="en-US" dirty="0">
+              <a:solidFill>
+                <a:srgbClr val="0070C0"/>
+              </a:solidFill>
+            </a:endParaRPr>
+          </a:p>
+          <a:p>
+            <a:endParaRPr lang="en-US" dirty="0">
+              <a:solidFill>
+                <a:srgbClr val="0070C0"/>
+              </a:solidFill>
+            </a:endParaRPr>
+          </a:p>
+          <a:p>
+            <a:endParaRPr lang="en-IN" dirty="0"/>
+          </a:p>
+        </p:txBody>
+      </p:sp>
+    </p:spTree>
+    <p:extLst>
+      <p:ext uri="{BB962C8B-B14F-4D97-AF65-F5344CB8AC3E}">
+        <p14:creationId xmlns:p14="http://schemas.microsoft.com/office/powerpoint/2010/main" val="4039476241"/>
+      </p:ext>
+    </p:extLst>
+  </p:cSld>
+  <p:clrMapOvr>
+    <a:masterClrMapping/>
+  </p:clrMapOvr>
+</p:sld>
+</file>
+
+<file path=ppt/slides/slide13.xml><?xml version="1.0" encoding="utf-8"?>
+<p:sld xmlns:a="http://schemas.openxmlformats.org/drawingml/2006/main" xmlns:r="http://schemas.openxmlformats.org/officeDocument/2006/relationships" xmlns:p="http://schemas.openxmlformats.org/presentationml/2006/main">
+  <p:cSld>
+    <p:spTree>
+      <p:nvGrpSpPr>
+        <p:cNvPr id="1" name=""/>
+        <p:cNvGrpSpPr/>
+        <p:nvPr/>
+      </p:nvGrpSpPr>
+      <p:grpSpPr>
+        <a:xfrm>
+          <a:off x="0" y="0"/>
+          <a:ext cx="0" cy="0"/>
+          <a:chOff x="0" y="0"/>
+          <a:chExt cx="0" cy="0"/>
+        </a:xfrm>
+      </p:grpSpPr>
+      <p:sp>
+        <p:nvSpPr>
+          <p:cNvPr id="2" name="Title 1">
+            <a:extLst>
+              <a:ext uri="{FF2B5EF4-FFF2-40B4-BE49-F238E27FC236}">
+                <a16:creationId xmlns:a16="http://schemas.microsoft.com/office/drawing/2014/main" id="{CD321DC2-7092-BC9F-EA80-6C58B3FA47D0}"/>
+              </a:ext>
+            </a:extLst>
+          </p:cNvPr>
+          <p:cNvSpPr>
+            <a:spLocks noGrp="1"/>
+          </p:cNvSpPr>
+          <p:nvPr>
+            <p:ph type="title"/>
+          </p:nvPr>
+        </p:nvSpPr>
+        <p:spPr/>
+        <p:txBody>
+          <a:bodyPr/>
+          <a:lstStyle/>
+          <a:p>
+            <a:endParaRPr lang="en-IN"/>
+          </a:p>
+        </p:txBody>
+      </p:sp>
+      <p:sp>
+        <p:nvSpPr>
+          <p:cNvPr id="3" name="Content Placeholder 2">
+            <a:extLst>
+              <a:ext uri="{FF2B5EF4-FFF2-40B4-BE49-F238E27FC236}">
+                <a16:creationId xmlns:a16="http://schemas.microsoft.com/office/drawing/2014/main" id="{1D32A713-D66E-6D1E-4EB6-8F247A2AC7CE}"/>
+              </a:ext>
+            </a:extLst>
+          </p:cNvPr>
+          <p:cNvSpPr>
+            <a:spLocks noGrp="1"/>
+          </p:cNvSpPr>
+          <p:nvPr>
+            <p:ph idx="1"/>
+          </p:nvPr>
+        </p:nvSpPr>
+        <p:spPr/>
+        <p:txBody>
+          <a:bodyPr/>
+          <a:lstStyle/>
+          <a:p>
+            <a:endParaRPr lang="en-IN"/>
+          </a:p>
+        </p:txBody>
+      </p:sp>
+    </p:spTree>
+    <p:extLst>
+      <p:ext uri="{BB962C8B-B14F-4D97-AF65-F5344CB8AC3E}">
+        <p14:creationId xmlns:p14="http://schemas.microsoft.com/office/powerpoint/2010/main" val="960029796"/>
+      </p:ext>
+    </p:extLst>
+  </p:cSld>
+  <p:clrMapOvr>
+    <a:masterClrMapping/>
+  </p:clrMapOvr>
+</p:sld>
+</file>
+
+<file path=ppt/slides/slide14.xml><?xml version="1.0" encoding="utf-8"?>
+<p:sld xmlns:a="http://schemas.openxmlformats.org/drawingml/2006/main" xmlns:r="http://schemas.openxmlformats.org/officeDocument/2006/relationships" xmlns:p="http://schemas.openxmlformats.org/presentationml/2006/main">
+  <p:cSld>
+    <p:spTree>
+      <p:nvGrpSpPr>
+        <p:cNvPr id="1" name=""/>
+        <p:cNvGrpSpPr/>
+        <p:nvPr/>
+      </p:nvGrpSpPr>
+      <p:grpSpPr>
+        <a:xfrm>
+          <a:off x="0" y="0"/>
+          <a:ext cx="0" cy="0"/>
+          <a:chOff x="0" y="0"/>
+          <a:chExt cx="0" cy="0"/>
+        </a:xfrm>
+      </p:grpSpPr>
+      <p:sp>
+        <p:nvSpPr>
           <p:cNvPr id="3" name="Content Placeholder 2">
             <a:extLst>
               <a:ext uri="{FF2B5EF4-FFF2-40B4-BE49-F238E27FC236}">
@@ -6517,10 +7511,10 @@
       </p:grpSpPr>
       <p:sp>
         <p:nvSpPr>
-          <p:cNvPr id="2" name="Title 1">
-            <a:extLst>
-              <a:ext uri="{FF2B5EF4-FFF2-40B4-BE49-F238E27FC236}">
-                <a16:creationId xmlns:a16="http://schemas.microsoft.com/office/drawing/2014/main" id="{2023C268-0263-861B-E91A-10861DDA3F2A}"/>
+          <p:cNvPr id="3" name="Content Placeholder 2">
+            <a:extLst>
+              <a:ext uri="{FF2B5EF4-FFF2-40B4-BE49-F238E27FC236}">
+                <a16:creationId xmlns:a16="http://schemas.microsoft.com/office/drawing/2014/main" id="{EDAA31A6-3489-847A-468D-43C173660CAA}"/>
               </a:ext>
             </a:extLst>
           </p:cNvPr>
@@ -6528,320 +7522,104 @@
             <a:spLocks noGrp="1"/>
           </p:cNvSpPr>
           <p:nvPr>
-            <p:ph type="title"/>
-          </p:nvPr>
-        </p:nvSpPr>
-        <p:spPr/>
+            <p:ph idx="1"/>
+          </p:nvPr>
+        </p:nvSpPr>
+        <p:spPr>
+          <a:xfrm>
+            <a:off x="344129" y="245806"/>
+            <a:ext cx="11631561" cy="6351639"/>
+          </a:xfrm>
+        </p:spPr>
         <p:txBody>
           <a:bodyPr/>
           <a:lstStyle/>
           <a:p>
-            <a:r>
-              <a:rPr lang="en-US" dirty="0"/>
-              <a:t>Commands to learned😁</a:t>
-            </a:r>
-            <a:endParaRPr lang="en-IN" dirty="0"/>
-          </a:p>
-        </p:txBody>
-      </p:sp>
-      <p:sp>
-        <p:nvSpPr>
-          <p:cNvPr id="3" name="Content Placeholder 2">
-            <a:extLst>
-              <a:ext uri="{FF2B5EF4-FFF2-40B4-BE49-F238E27FC236}">
-                <a16:creationId xmlns:a16="http://schemas.microsoft.com/office/drawing/2014/main" id="{164FD01D-C4BC-B66B-A186-946FDDFF6F92}"/>
-              </a:ext>
-            </a:extLst>
-          </p:cNvPr>
-          <p:cNvSpPr>
-            <a:spLocks noGrp="1"/>
-          </p:cNvSpPr>
-          <p:nvPr>
-            <p:ph idx="1"/>
-          </p:nvPr>
-        </p:nvSpPr>
-        <p:spPr>
-          <a:xfrm>
-            <a:off x="838200" y="1533832"/>
-            <a:ext cx="10515600" cy="4643131"/>
-          </a:xfrm>
-        </p:spPr>
-        <p:txBody>
-          <a:bodyPr>
-            <a:normAutofit lnSpcReduction="10000"/>
-          </a:bodyPr>
-          <a:lstStyle/>
-          <a:p>
-            <a:pPr marL="0" indent="0">
-              <a:buNone/>
-            </a:pPr>
-            <a:r>
-              <a:rPr lang="en-US" sz="3200" dirty="0">
-                <a:solidFill>
-                  <a:srgbClr val="0070C0"/>
-                </a:solidFill>
-              </a:rPr>
-              <a:t>git clone “</a:t>
-            </a:r>
-            <a:r>
-              <a:rPr lang="en-US" sz="3200" dirty="0" err="1">
-                <a:solidFill>
-                  <a:schemeClr val="accent6"/>
-                </a:solidFill>
-              </a:rPr>
-              <a:t>url</a:t>
-            </a:r>
-            <a:r>
-              <a:rPr lang="en-US" sz="3200" dirty="0">
-                <a:solidFill>
-                  <a:schemeClr val="accent6"/>
-                </a:solidFill>
-              </a:rPr>
-              <a:t> of main branch</a:t>
-            </a:r>
-            <a:r>
-              <a:rPr lang="en-US" sz="3200" dirty="0">
-                <a:solidFill>
-                  <a:srgbClr val="0070C0"/>
-                </a:solidFill>
-              </a:rPr>
-              <a:t>”</a:t>
-            </a:r>
-          </a:p>
-          <a:p>
-            <a:pPr marL="0" indent="0">
-              <a:buNone/>
-            </a:pPr>
-            <a:r>
-              <a:rPr lang="en-US" sz="3200" dirty="0">
-                <a:solidFill>
-                  <a:srgbClr val="0070C0"/>
-                </a:solidFill>
-              </a:rPr>
-              <a:t>git clone “</a:t>
-            </a:r>
-            <a:r>
-              <a:rPr lang="en-US" sz="3200" dirty="0" err="1">
-                <a:solidFill>
-                  <a:schemeClr val="accent6"/>
-                </a:solidFill>
-              </a:rPr>
-              <a:t>url</a:t>
-            </a:r>
-            <a:r>
-              <a:rPr lang="en-US" sz="3200" dirty="0">
-                <a:solidFill>
-                  <a:schemeClr val="accent6"/>
-                </a:solidFill>
-              </a:rPr>
-              <a:t> of main branch</a:t>
-            </a:r>
-            <a:r>
-              <a:rPr lang="en-US" sz="3200" dirty="0">
-                <a:solidFill>
-                  <a:srgbClr val="0070C0"/>
-                </a:solidFill>
-              </a:rPr>
-              <a:t>”--branch=“</a:t>
-            </a:r>
-            <a:r>
-              <a:rPr lang="en-US" sz="3200" dirty="0" err="1">
-                <a:solidFill>
-                  <a:schemeClr val="accent6"/>
-                </a:solidFill>
-              </a:rPr>
-              <a:t>branch_name</a:t>
-            </a:r>
-            <a:r>
-              <a:rPr lang="en-US" sz="3200" dirty="0">
-                <a:solidFill>
-                  <a:srgbClr val="0070C0"/>
-                </a:solidFill>
-              </a:rPr>
-              <a:t>”</a:t>
-            </a:r>
-          </a:p>
-          <a:p>
-            <a:pPr marL="0" indent="0">
-              <a:buNone/>
-            </a:pPr>
-            <a:r>
-              <a:rPr lang="en-US" sz="3200" dirty="0">
-                <a:solidFill>
-                  <a:srgbClr val="0070C0"/>
-                </a:solidFill>
-              </a:rPr>
-              <a:t>git branch</a:t>
-            </a:r>
-          </a:p>
-          <a:p>
-            <a:pPr marL="0" indent="0">
-              <a:buNone/>
-            </a:pPr>
-            <a:r>
-              <a:rPr lang="en-US" sz="3200" dirty="0">
-                <a:solidFill>
-                  <a:srgbClr val="0070C0"/>
-                </a:solidFill>
-              </a:rPr>
-              <a:t>git checkout “</a:t>
-            </a:r>
-            <a:r>
-              <a:rPr lang="en-US" sz="3200" dirty="0">
-                <a:solidFill>
-                  <a:schemeClr val="accent6"/>
-                </a:solidFill>
-              </a:rPr>
-              <a:t>choose</a:t>
-            </a:r>
-            <a:r>
-              <a:rPr lang="en-US" sz="3200" dirty="0">
-                <a:solidFill>
-                  <a:srgbClr val="0070C0"/>
-                </a:solidFill>
-              </a:rPr>
+            <a:pPr marL="0" indent="0">
+              <a:buNone/>
+            </a:pPr>
+            <a:r>
+              <a:rPr lang="en-US" dirty="0"/>
+              <a:t>To find the file are staged how can we check using </a:t>
+            </a:r>
+          </a:p>
+          <a:p>
+            <a:pPr marL="0" indent="0">
+              <a:buNone/>
+            </a:pPr>
+            <a:r>
+              <a:rPr lang="en-US" dirty="0"/>
+              <a:t>File1.txt is staged and </a:t>
+            </a:r>
+            <a:r>
+              <a:rPr lang="en-US" dirty="0" err="1"/>
+              <a:t>commited</a:t>
+            </a:r>
+            <a:r>
+              <a:rPr lang="en-US" dirty="0"/>
               <a:t> </a:t>
             </a:r>
-            <a:r>
-              <a:rPr lang="en-US" sz="3200" dirty="0">
-                <a:solidFill>
-                  <a:schemeClr val="accent6"/>
-                </a:solidFill>
-              </a:rPr>
-              <a:t>the branch name</a:t>
-            </a:r>
-            <a:r>
-              <a:rPr lang="en-US" sz="3200" dirty="0">
-                <a:solidFill>
-                  <a:srgbClr val="0070C0"/>
-                </a:solidFill>
-              </a:rPr>
-              <a:t>" </a:t>
-            </a:r>
-          </a:p>
-          <a:p>
-            <a:pPr marL="0" indent="0">
-              <a:buNone/>
-            </a:pPr>
-            <a:r>
-              <a:rPr lang="en-US" sz="3200" dirty="0">
-                <a:solidFill>
-                  <a:srgbClr val="0070C0"/>
-                </a:solidFill>
-              </a:rPr>
-              <a:t>git add .</a:t>
-            </a:r>
-          </a:p>
-          <a:p>
-            <a:pPr marL="0" indent="0">
-              <a:buNone/>
-            </a:pPr>
-            <a:r>
-              <a:rPr lang="en-US" sz="3200" dirty="0">
-                <a:solidFill>
-                  <a:srgbClr val="0070C0"/>
-                </a:solidFill>
-              </a:rPr>
-              <a:t>git reset </a:t>
-            </a:r>
-            <a:r>
-              <a:rPr lang="en-US" sz="3200" dirty="0" err="1">
-                <a:solidFill>
-                  <a:schemeClr val="accent6"/>
-                </a:solidFill>
-              </a:rPr>
-              <a:t>staged_filename</a:t>
-            </a:r>
-            <a:endParaRPr lang="en-US" sz="3200" dirty="0">
-              <a:solidFill>
-                <a:schemeClr val="accent6"/>
-              </a:solidFill>
-            </a:endParaRPr>
-          </a:p>
-          <a:p>
-            <a:pPr marL="0" indent="0">
-              <a:buNone/>
-            </a:pPr>
-            <a:r>
-              <a:rPr lang="en-US" sz="3200" dirty="0">
-                <a:solidFill>
-                  <a:srgbClr val="0070C0"/>
-                </a:solidFill>
-              </a:rPr>
-              <a:t>git commit –m “</a:t>
-            </a:r>
-            <a:r>
-              <a:rPr lang="en-US" sz="3200" dirty="0">
-                <a:solidFill>
-                  <a:schemeClr val="accent6"/>
-                </a:solidFill>
-              </a:rPr>
-              <a:t>commit</a:t>
-            </a:r>
-            <a:r>
-              <a:rPr lang="en-US" sz="3200" dirty="0">
-                <a:solidFill>
-                  <a:srgbClr val="0070C0"/>
-                </a:solidFill>
-              </a:rPr>
+          </a:p>
+          <a:p>
+            <a:pPr marL="0" indent="0">
+              <a:buNone/>
+            </a:pPr>
+            <a:r>
+              <a:rPr lang="en-US" dirty="0"/>
+              <a:t>file2.txt is not staged and not </a:t>
+            </a:r>
+            <a:r>
+              <a:rPr lang="en-US" dirty="0" err="1"/>
+              <a:t>commited</a:t>
+            </a:r>
+            <a:r>
+              <a:rPr lang="en-US" dirty="0"/>
               <a:t> </a:t>
             </a:r>
-            <a:r>
-              <a:rPr lang="en-US" sz="3200" dirty="0">
-                <a:solidFill>
-                  <a:schemeClr val="accent6"/>
-                </a:solidFill>
-              </a:rPr>
-              <a:t>message</a:t>
-            </a:r>
-            <a:r>
-              <a:rPr lang="en-US" sz="3200" dirty="0">
-                <a:solidFill>
-                  <a:srgbClr val="0070C0"/>
-                </a:solidFill>
-              </a:rPr>
-              <a:t>”</a:t>
-            </a:r>
-          </a:p>
-          <a:p>
-            <a:pPr marL="0" indent="0">
-              <a:buNone/>
-            </a:pPr>
-            <a:r>
-              <a:rPr lang="en-US" sz="3200" dirty="0">
-                <a:solidFill>
-                  <a:srgbClr val="0070C0"/>
-                </a:solidFill>
-              </a:rPr>
-              <a:t>git push</a:t>
-            </a:r>
-          </a:p>
-          <a:p>
-            <a:pPr marL="0" indent="0">
-              <a:buNone/>
-            </a:pPr>
-            <a:r>
-              <a:rPr lang="en-US" sz="3200" dirty="0">
-                <a:solidFill>
-                  <a:srgbClr val="0070C0"/>
-                </a:solidFill>
-              </a:rPr>
-              <a:t>git push origin </a:t>
-            </a:r>
-            <a:r>
-              <a:rPr lang="en-US" sz="3200" dirty="0" err="1">
-                <a:solidFill>
-                  <a:schemeClr val="accent6"/>
-                </a:solidFill>
-              </a:rPr>
-              <a:t>branchname</a:t>
-            </a:r>
-            <a:r>
-              <a:rPr lang="en-US" sz="3200" dirty="0">
-                <a:solidFill>
-                  <a:srgbClr val="0070C0"/>
-                </a:solidFill>
-              </a:rPr>
+          </a:p>
+          <a:p>
+            <a:pPr marL="0" indent="0">
+              <a:buNone/>
+            </a:pPr>
+            <a:r>
+              <a:rPr lang="en-US" dirty="0">
+                <a:solidFill>
+                  <a:schemeClr val="accent1"/>
+                </a:solidFill>
+              </a:rPr>
+              <a:t>Git status --To check the file which are </a:t>
+            </a:r>
+            <a:r>
+              <a:rPr lang="en-US" dirty="0" err="1">
+                <a:solidFill>
+                  <a:schemeClr val="accent1"/>
+                </a:solidFill>
+              </a:rPr>
+              <a:t>unstaged</a:t>
+            </a:r>
+            <a:r>
+              <a:rPr lang="en-US" dirty="0">
+                <a:solidFill>
+                  <a:schemeClr val="accent1"/>
+                </a:solidFill>
+              </a:rPr>
+              <a:t> or untracked </a:t>
+            </a:r>
+          </a:p>
+          <a:p>
+            <a:pPr marL="0" indent="0">
+              <a:buNone/>
+            </a:pPr>
+            <a:r>
+              <a:rPr lang="en-US" dirty="0"/>
+              <a:t>Here we can see the file2.txt is </a:t>
+            </a:r>
+            <a:r>
+              <a:rPr lang="en-US" dirty="0" err="1"/>
+              <a:t>unstaged</a:t>
+            </a:r>
+            <a:r>
+              <a:rPr lang="en-US" dirty="0"/>
               <a:t> </a:t>
             </a:r>
           </a:p>
@@ -6849,35 +7627,98 @@
             <a:pPr marL="0" indent="0">
               <a:buNone/>
             </a:pPr>
-            <a:endParaRPr lang="en-US" dirty="0">
-              <a:solidFill>
-                <a:srgbClr val="0070C0"/>
-              </a:solidFill>
-            </a:endParaRPr>
-          </a:p>
-          <a:p>
-            <a:endParaRPr lang="en-US" dirty="0">
-              <a:solidFill>
-                <a:srgbClr val="0070C0"/>
-              </a:solidFill>
-            </a:endParaRPr>
-          </a:p>
-          <a:p>
-            <a:endParaRPr lang="en-US" dirty="0">
-              <a:solidFill>
-                <a:srgbClr val="0070C0"/>
-              </a:solidFill>
-            </a:endParaRPr>
-          </a:p>
-          <a:p>
-            <a:endParaRPr lang="en-IN" dirty="0"/>
+            <a:endParaRPr lang="en-US" dirty="0"/>
+          </a:p>
+          <a:p>
+            <a:pPr marL="0" indent="0">
+              <a:buNone/>
+            </a:pPr>
+            <a:r>
+              <a:rPr lang="en-US" dirty="0"/>
+              <a:t>Next  done the git add but not </a:t>
+            </a:r>
+            <a:r>
+              <a:rPr lang="en-US" dirty="0" err="1"/>
+              <a:t>commited</a:t>
+            </a:r>
+            <a:r>
+              <a:rPr lang="en-US" dirty="0"/>
+              <a:t> how can we track that is </a:t>
+            </a:r>
+            <a:r>
+              <a:rPr lang="en-US" dirty="0" err="1"/>
+              <a:t>commited</a:t>
+            </a:r>
+            <a:r>
+              <a:rPr lang="en-US" dirty="0"/>
+              <a:t> or not </a:t>
+            </a:r>
+          </a:p>
+          <a:p>
+            <a:pPr marL="0" indent="0">
+              <a:buNone/>
+            </a:pPr>
+            <a:r>
+              <a:rPr lang="en-US" dirty="0">
+                <a:solidFill>
+                  <a:schemeClr val="accent1"/>
+                </a:solidFill>
+              </a:rPr>
+              <a:t>Git add file2.txt here-&gt;file2.txt is staged but not </a:t>
+            </a:r>
+            <a:r>
+              <a:rPr lang="en-US" dirty="0" err="1">
+                <a:solidFill>
+                  <a:schemeClr val="accent1"/>
+                </a:solidFill>
+              </a:rPr>
+              <a:t>commited</a:t>
+            </a:r>
+            <a:r>
+              <a:rPr lang="en-US" dirty="0">
+                <a:solidFill>
+                  <a:schemeClr val="accent1"/>
+                </a:solidFill>
+              </a:rPr>
+              <a:t> then </a:t>
+            </a:r>
+          </a:p>
+          <a:p>
+            <a:pPr marL="0" indent="0">
+              <a:buNone/>
+            </a:pPr>
+            <a:r>
+              <a:rPr lang="en-US" dirty="0">
+                <a:solidFill>
+                  <a:schemeClr val="accent1"/>
+                </a:solidFill>
+              </a:rPr>
+              <a:t>Git status -&gt;</a:t>
+            </a:r>
+          </a:p>
+          <a:p>
+            <a:pPr marL="0" indent="0">
+              <a:buNone/>
+            </a:pPr>
+            <a:r>
+              <a:rPr lang="en-US" dirty="0"/>
+              <a:t>Here we can find the file2.txt Is not </a:t>
+            </a:r>
+            <a:r>
+              <a:rPr lang="en-US" dirty="0" err="1"/>
+              <a:t>commited</a:t>
+            </a:r>
+            <a:r>
+              <a:rPr lang="en-US" dirty="0"/>
+              <a:t> (line after line)</a:t>
+            </a:r>
           </a:p>
         </p:txBody>
       </p:sp>
     </p:spTree>
     <p:extLst>
       <p:ext uri="{BB962C8B-B14F-4D97-AF65-F5344CB8AC3E}">
-        <p14:creationId xmlns:p14="http://schemas.microsoft.com/office/powerpoint/2010/main" val="4039476241"/>
+        <p14:creationId xmlns:p14="http://schemas.microsoft.com/office/powerpoint/2010/main" val="2642619703"/>
       </p:ext>
     </p:extLst>
   </p:cSld>
@@ -6906,10 +7747,10 @@
       </p:grpSpPr>
       <p:sp>
         <p:nvSpPr>
-          <p:cNvPr id="2" name="Title 1">
-            <a:extLst>
-              <a:ext uri="{FF2B5EF4-FFF2-40B4-BE49-F238E27FC236}">
-                <a16:creationId xmlns:a16="http://schemas.microsoft.com/office/drawing/2014/main" id="{CD321DC2-7092-BC9F-EA80-6C58B3FA47D0}"/>
+          <p:cNvPr id="3" name="Content Placeholder 2">
+            <a:extLst>
+              <a:ext uri="{FF2B5EF4-FFF2-40B4-BE49-F238E27FC236}">
+                <a16:creationId xmlns:a16="http://schemas.microsoft.com/office/drawing/2014/main" id="{B83CD728-0F5D-59D4-F090-3D5123F39EBE}"/>
               </a:ext>
             </a:extLst>
           </p:cNvPr>
@@ -6917,47 +7758,222 @@
             <a:spLocks noGrp="1"/>
           </p:cNvSpPr>
           <p:nvPr>
-            <p:ph type="title"/>
-          </p:nvPr>
-        </p:nvSpPr>
-        <p:spPr/>
-        <p:txBody>
-          <a:bodyPr/>
+            <p:ph idx="1"/>
+          </p:nvPr>
+        </p:nvSpPr>
+        <p:spPr>
+          <a:xfrm>
+            <a:off x="491613" y="275304"/>
+            <a:ext cx="10862187" cy="5931156"/>
+          </a:xfrm>
+        </p:spPr>
+        <p:txBody>
+          <a:bodyPr>
+            <a:normAutofit fontScale="77500" lnSpcReduction="20000"/>
+          </a:bodyPr>
           <a:lstStyle/>
           <a:p>
-            <a:endParaRPr lang="en-IN"/>
-          </a:p>
-        </p:txBody>
-      </p:sp>
-      <p:sp>
-        <p:nvSpPr>
-          <p:cNvPr id="3" name="Content Placeholder 2">
-            <a:extLst>
-              <a:ext uri="{FF2B5EF4-FFF2-40B4-BE49-F238E27FC236}">
-                <a16:creationId xmlns:a16="http://schemas.microsoft.com/office/drawing/2014/main" id="{1D32A713-D66E-6D1E-4EB6-8F247A2AC7CE}"/>
-              </a:ext>
-            </a:extLst>
-          </p:cNvPr>
-          <p:cNvSpPr>
-            <a:spLocks noGrp="1"/>
-          </p:cNvSpPr>
-          <p:nvPr>
-            <p:ph idx="1"/>
-          </p:nvPr>
-        </p:nvSpPr>
-        <p:spPr/>
-        <p:txBody>
-          <a:bodyPr/>
-          <a:lstStyle/>
-          <a:p>
-            <a:endParaRPr lang="en-IN"/>
+            <a:pPr marL="0" indent="0">
+              <a:buNone/>
+            </a:pPr>
+            <a:r>
+              <a:rPr lang="en-US" dirty="0">
+                <a:solidFill>
+                  <a:schemeClr val="accent1"/>
+                </a:solidFill>
+              </a:rPr>
+              <a:t>Git diff </a:t>
+            </a:r>
+          </a:p>
+          <a:p>
+            <a:pPr marL="0" indent="0">
+              <a:buNone/>
+            </a:pPr>
+            <a:r>
+              <a:rPr lang="en-US" dirty="0"/>
+              <a:t>Show the modified with original one </a:t>
+            </a:r>
+          </a:p>
+          <a:p>
+            <a:pPr marL="0" indent="0">
+              <a:buNone/>
+            </a:pPr>
+            <a:r>
+              <a:rPr lang="en-US" dirty="0"/>
+              <a:t>Hai=original in file1.txt</a:t>
+            </a:r>
+          </a:p>
+          <a:p>
+            <a:pPr marL="0" indent="0">
+              <a:buNone/>
+            </a:pPr>
+            <a:r>
+              <a:rPr lang="en-US" dirty="0"/>
+              <a:t>Change the file1.txt to </a:t>
+            </a:r>
+          </a:p>
+          <a:p>
+            <a:pPr marL="0" indent="0">
+              <a:buNone/>
+            </a:pPr>
+            <a:r>
+              <a:rPr lang="en-US" dirty="0" err="1"/>
+              <a:t>hai</a:t>
+            </a:r>
+            <a:r>
+              <a:rPr lang="en-US" dirty="0"/>
+              <a:t> rain</a:t>
+            </a:r>
+          </a:p>
+          <a:p>
+            <a:pPr marL="0" indent="0">
+              <a:buNone/>
+            </a:pPr>
+            <a:r>
+              <a:rPr lang="en-US" dirty="0"/>
+              <a:t>To see what changed </a:t>
+            </a:r>
+            <a:r>
+              <a:rPr lang="en-US" dirty="0">
+                <a:solidFill>
+                  <a:schemeClr val="accent1"/>
+                </a:solidFill>
+              </a:rPr>
+              <a:t>– git diff</a:t>
+            </a:r>
+          </a:p>
+          <a:p>
+            <a:pPr marL="0" indent="0">
+              <a:buNone/>
+            </a:pPr>
+            <a:r>
+              <a:rPr lang="en-US" dirty="0"/>
+              <a:t>-</a:t>
+            </a:r>
+            <a:r>
+              <a:rPr lang="en-US" dirty="0" err="1"/>
+              <a:t>hai</a:t>
+            </a:r>
+            <a:endParaRPr lang="en-US" dirty="0"/>
+          </a:p>
+          <a:p>
+            <a:pPr marL="0" indent="0">
+              <a:buNone/>
+            </a:pPr>
+            <a:r>
+              <a:rPr lang="en-US" dirty="0"/>
+              <a:t>+</a:t>
+            </a:r>
+            <a:r>
+              <a:rPr lang="en-US" dirty="0" err="1"/>
+              <a:t>hai</a:t>
+            </a:r>
+            <a:r>
+              <a:rPr lang="en-US" dirty="0"/>
+              <a:t> rain</a:t>
+            </a:r>
+          </a:p>
+          <a:p>
+            <a:pPr marL="0" indent="0">
+              <a:buNone/>
+            </a:pPr>
+            <a:endParaRPr lang="en-US" dirty="0"/>
+          </a:p>
+          <a:p>
+            <a:pPr marL="0" indent="0">
+              <a:buNone/>
+            </a:pPr>
+            <a:r>
+              <a:rPr lang="en-US" dirty="0"/>
+              <a:t>Before pushing to the main branch we need to take the pull from main</a:t>
+            </a:r>
+          </a:p>
+          <a:p>
+            <a:pPr marL="0" indent="0">
+              <a:buNone/>
+            </a:pPr>
+            <a:r>
+              <a:rPr lang="en-US" dirty="0"/>
+              <a:t>And push the changes in the main</a:t>
+            </a:r>
+          </a:p>
+          <a:p>
+            <a:pPr marL="0" indent="0">
+              <a:buNone/>
+            </a:pPr>
+            <a:r>
+              <a:rPr lang="en-US" dirty="0"/>
+              <a:t>If the not pulled means the recent changes of coworker in code (code misses)</a:t>
+            </a:r>
+          </a:p>
+          <a:p>
+            <a:pPr marL="0" indent="0">
+              <a:buNone/>
+            </a:pPr>
+            <a:r>
+              <a:rPr lang="en-US" dirty="0"/>
+              <a:t>If the change the same line what you need to change means </a:t>
+            </a:r>
+            <a:r>
+              <a:rPr lang="en-US" dirty="0">
+                <a:solidFill>
+                  <a:schemeClr val="accent1"/>
+                </a:solidFill>
+              </a:rPr>
+              <a:t>first pull and push </a:t>
+            </a:r>
+            <a:r>
+              <a:rPr lang="en-US" dirty="0"/>
+              <a:t>at the time if not pulled means it </a:t>
+            </a:r>
+            <a:r>
+              <a:rPr lang="en-US" dirty="0" err="1"/>
+              <a:t>thows</a:t>
+            </a:r>
+            <a:r>
+              <a:rPr lang="en-US" dirty="0"/>
+              <a:t> error </a:t>
+            </a:r>
+            <a:r>
+              <a:rPr lang="en-US" dirty="0" err="1"/>
+              <a:t>firt</a:t>
+            </a:r>
+            <a:r>
+              <a:rPr lang="en-US" dirty="0"/>
+              <a:t> pull and then push</a:t>
+            </a:r>
+          </a:p>
+          <a:p>
+            <a:pPr marL="0" indent="0">
+              <a:buNone/>
+            </a:pPr>
+            <a:r>
+              <a:rPr lang="en-US" dirty="0"/>
+              <a:t>Git pull given </a:t>
+            </a:r>
+            <a:br>
+              <a:rPr lang="en-US" dirty="0"/>
+            </a:br>
+            <a:r>
+              <a:rPr lang="en-US" dirty="0"/>
+              <a:t>if coworker and you changed the same line in the code it throws merge </a:t>
+            </a:r>
+            <a:r>
+              <a:rPr lang="en-US" dirty="0" err="1"/>
+              <a:t>confict</a:t>
+            </a:r>
+            <a:r>
+              <a:rPr lang="en-US" dirty="0"/>
+              <a:t> that do be resolved with teammates and then push which is necessary  .</a:t>
+            </a:r>
+            <a:endParaRPr lang="en-IN" dirty="0"/>
           </a:p>
         </p:txBody>
       </p:sp>
     </p:spTree>
     <p:extLst>
       <p:ext uri="{BB962C8B-B14F-4D97-AF65-F5344CB8AC3E}">
-        <p14:creationId xmlns:p14="http://schemas.microsoft.com/office/powerpoint/2010/main" val="960029796"/>
+        <p14:creationId xmlns:p14="http://schemas.microsoft.com/office/powerpoint/2010/main" val="2001776625"/>
       </p:ext>
     </p:extLst>
   </p:cSld>

</xml_diff>